<commit_message>
update slide and note
</commit_message>
<xml_diff>
--- a/slides/bao-cao-buoi-1-nhan-dang-hanh-dong.pptx
+++ b/slides/bao-cao-buoi-1-nhan-dang-hanh-dong.pptx
@@ -2291,18 +2291,7 @@
                 <a:ea typeface="Calibri" pitchFamily="34" charset="-122"/>
                 <a:cs typeface="Calibri" pitchFamily="34" charset="-120"/>
               </a:rPr>
-              <a:t>Nguyễn Tiến Lâm</a:t>
-            </a:r>
-            <a:r>
-              <a:rPr lang="en-US" sz="1250" dirty="0" smtClean="0">
-                <a:solidFill>
-                  <a:srgbClr val="92A2B8"/>
-                </a:solidFill>
-                <a:latin typeface="Calibri" pitchFamily="34" charset="0"/>
-                <a:ea typeface="Calibri" pitchFamily="34" charset="-122"/>
-                <a:cs typeface="Calibri" pitchFamily="34" charset="-120"/>
-              </a:rPr>
-              <a:t>  </a:t>
+              <a:t>Nguyễn Tiến Lâm  </a:t>
             </a:r>
             <a:r>
               <a:rPr lang="en-US" sz="1250" dirty="0">
@@ -4752,7 +4741,29 @@
                 <a:ea typeface="Calibri" pitchFamily="34" charset="-122"/>
                 <a:cs typeface="Calibri" pitchFamily="34" charset="-120"/>
               </a:rPr>
-              <a:t>OpenCV mở webcam và đọc từng khung hình, khoảng 30 khung mỗi giây. Đây cũng là chỗ đặt bộ đếm FPS để biết hệ thống có chạy kịp thời gian thực hay không.</a:t>
+              <a:t>OpenCV mở webcam và đọc từng khung hình, khoảng 30 khung mỗi </a:t>
+            </a:r>
+            <a:r>
+              <a:rPr lang="en-US" sz="1100" dirty="0" err="1">
+                <a:solidFill>
+                  <a:srgbClr val="3C4A5C"/>
+                </a:solidFill>
+                <a:latin typeface="Calibri" pitchFamily="34" charset="0"/>
+                <a:ea typeface="Calibri" pitchFamily="34" charset="-122"/>
+                <a:cs typeface="Calibri" pitchFamily="34" charset="-120"/>
+              </a:rPr>
+              <a:t>giây</a:t>
+            </a:r>
+            <a:r>
+              <a:rPr lang="en-US" sz="1100" dirty="0" smtClean="0">
+                <a:solidFill>
+                  <a:srgbClr val="3C4A5C"/>
+                </a:solidFill>
+                <a:latin typeface="Calibri" pitchFamily="34" charset="0"/>
+                <a:ea typeface="Calibri" pitchFamily="34" charset="-122"/>
+                <a:cs typeface="Calibri" pitchFamily="34" charset="-120"/>
+              </a:rPr>
+              <a:t>.</a:t>
             </a:r>
             <a:endParaRPr lang="en-US" sz="1100" dirty="0"/>
           </a:p>
@@ -4924,7 +4935,51 @@
                 <a:ea typeface="Calibri" pitchFamily="34" charset="-122"/>
                 <a:cs typeface="Calibri" pitchFamily="34" charset="-120"/>
               </a:rPr>
-              <a:t>Chuyển ảnh sang RGB rồi đưa vào MediaPipe Pose. Mô hình trả về 33 điểm khớp kèm điểm tin cậy. Từ đây hệ thống không làm việc với pixel nữa, chỉ còn tọa độ.</a:t>
+              <a:t>Chuyển ảnh sang RGB rồi đưa vào MediaPipe Pose. Mô hình trả về 33 </a:t>
+            </a:r>
+            <a:r>
+              <a:rPr lang="en-US" sz="1100" dirty="0" err="1">
+                <a:solidFill>
+                  <a:srgbClr val="3C4A5C"/>
+                </a:solidFill>
+                <a:latin typeface="Calibri" pitchFamily="34" charset="0"/>
+                <a:ea typeface="Calibri" pitchFamily="34" charset="-122"/>
+                <a:cs typeface="Calibri" pitchFamily="34" charset="-120"/>
+              </a:rPr>
+              <a:t>điểm</a:t>
+            </a:r>
+            <a:r>
+              <a:rPr lang="en-US" sz="1100" dirty="0">
+                <a:solidFill>
+                  <a:srgbClr val="3C4A5C"/>
+                </a:solidFill>
+                <a:latin typeface="Calibri" pitchFamily="34" charset="0"/>
+                <a:ea typeface="Calibri" pitchFamily="34" charset="-122"/>
+                <a:cs typeface="Calibri" pitchFamily="34" charset="-120"/>
+              </a:rPr>
+              <a:t> </a:t>
+            </a:r>
+            <a:r>
+              <a:rPr lang="en-US" sz="1100" dirty="0" err="1" smtClean="0">
+                <a:solidFill>
+                  <a:srgbClr val="3C4A5C"/>
+                </a:solidFill>
+                <a:latin typeface="Calibri" pitchFamily="34" charset="0"/>
+                <a:ea typeface="Calibri" pitchFamily="34" charset="-122"/>
+                <a:cs typeface="Calibri" pitchFamily="34" charset="-120"/>
+              </a:rPr>
+              <a:t>khớp</a:t>
+            </a:r>
+            <a:r>
+              <a:rPr lang="en-US" sz="1100" dirty="0">
+                <a:solidFill>
+                  <a:srgbClr val="3C4A5C"/>
+                </a:solidFill>
+                <a:latin typeface="Calibri" pitchFamily="34" charset="0"/>
+                <a:ea typeface="Calibri" pitchFamily="34" charset="-122"/>
+                <a:cs typeface="Calibri" pitchFamily="34" charset="-120"/>
+              </a:rPr>
+              <a:t>.</a:t>
             </a:r>
             <a:endParaRPr lang="en-US" sz="1100" dirty="0"/>
           </a:p>
@@ -5440,7 +5495,7 @@
                 <a:ea typeface="Calibri" pitchFamily="34" charset="-122"/>
                 <a:cs typeface="Calibri" pitchFamily="34" charset="-120"/>
               </a:rPr>
-              <a:t>Nhận cả cửa sổ 30 khung và trả về xác suất cho từng hành động. Giai đoạn đầu dùng rừng ngẫu nhiên, giai đoạn sau thay bằng LSTM để so sánh hai bên.</a:t>
+              <a:t>Nhận cả cửa sổ 30 khung và trả về xác suất cho từng hành động. </a:t>
             </a:r>
             <a:endParaRPr lang="en-US" sz="1100" dirty="0"/>
           </a:p>
@@ -5612,7 +5667,40 @@
                 <a:ea typeface="Calibri" pitchFamily="34" charset="-122"/>
                 <a:cs typeface="Calibri" pitchFamily="34" charset="-120"/>
               </a:rPr>
-              <a:t>Chọn nhãn có xác suất cao nhất, làm mượt bằng bỏ phiếu trên 5 dự đoán gần nhất để nhãn không nhảy, rồi vẽ nhãn và độ tin cậy đè lên khung hình.</a:t>
+              <a:t>Chọn nhãn có xác suất </a:t>
+            </a:r>
+            <a:r>
+              <a:rPr lang="en-US" sz="1100" dirty="0" err="1">
+                <a:solidFill>
+                  <a:srgbClr val="3C4A5C"/>
+                </a:solidFill>
+                <a:latin typeface="Calibri" pitchFamily="34" charset="0"/>
+                <a:ea typeface="Calibri" pitchFamily="34" charset="-122"/>
+                <a:cs typeface="Calibri" pitchFamily="34" charset="-120"/>
+              </a:rPr>
+              <a:t>cao</a:t>
+            </a:r>
+            <a:r>
+              <a:rPr lang="en-US" sz="1100" dirty="0">
+                <a:solidFill>
+                  <a:srgbClr val="3C4A5C"/>
+                </a:solidFill>
+                <a:latin typeface="Calibri" pitchFamily="34" charset="0"/>
+                <a:ea typeface="Calibri" pitchFamily="34" charset="-122"/>
+                <a:cs typeface="Calibri" pitchFamily="34" charset="-120"/>
+              </a:rPr>
+              <a:t> </a:t>
+            </a:r>
+            <a:r>
+              <a:rPr lang="en-US" sz="1100" dirty="0" err="1" smtClean="0">
+                <a:solidFill>
+                  <a:srgbClr val="3C4A5C"/>
+                </a:solidFill>
+                <a:latin typeface="Calibri" pitchFamily="34" charset="0"/>
+                <a:ea typeface="Calibri" pitchFamily="34" charset="-122"/>
+                <a:cs typeface="Calibri" pitchFamily="34" charset="-120"/>
+              </a:rPr>
+              <a:t>nhất</a:t>
             </a:r>
             <a:endParaRPr lang="en-US" sz="1100" dirty="0"/>
           </a:p>
@@ -6280,6 +6368,28 @@
               <a:buChar char="•"/>
             </a:pPr>
             <a:r>
+              <a:rPr lang="en-US" sz="1150" dirty="0" err="1" smtClean="0">
+                <a:solidFill>
+                  <a:srgbClr val="3C4A5C"/>
+                </a:solidFill>
+                <a:latin typeface="Calibri" pitchFamily="34" charset="0"/>
+                <a:ea typeface="Calibri" pitchFamily="34" charset="-122"/>
+                <a:cs typeface="Calibri" pitchFamily="34" charset="-120"/>
+              </a:rPr>
+              <a:t>Keypoint</a:t>
+            </a:r>
+            <a:r>
+              <a:rPr lang="en-US" sz="1150" dirty="0" smtClean="0">
+                <a:solidFill>
+                  <a:srgbClr val="3C4A5C"/>
+                </a:solidFill>
+                <a:latin typeface="Calibri" pitchFamily="34" charset="0"/>
+                <a:ea typeface="Calibri" pitchFamily="34" charset="-122"/>
+                <a:cs typeface="Calibri" pitchFamily="34" charset="-120"/>
+              </a:rPr>
+              <a:t>: </a:t>
+            </a:r>
+            <a:r>
               <a:rPr lang="en-US" sz="1150" dirty="0">
                 <a:solidFill>
                   <a:srgbClr val="3C4A5C"/>
@@ -6288,7 +6398,62 @@
                 <a:ea typeface="Calibri" pitchFamily="34" charset="-122"/>
                 <a:cs typeface="Calibri" pitchFamily="34" charset="-120"/>
               </a:rPr>
-              <a:t>Keypoint và bản đồ nhiệt: mô hình dự đoán xác suất khớp ở từng vị trí</a:t>
+              <a:t>mô hình </a:t>
+            </a:r>
+            <a:r>
+              <a:rPr lang="en-US" sz="1150" dirty="0" err="1">
+                <a:solidFill>
+                  <a:srgbClr val="3C4A5C"/>
+                </a:solidFill>
+                <a:latin typeface="Calibri" pitchFamily="34" charset="0"/>
+                <a:ea typeface="Calibri" pitchFamily="34" charset="-122"/>
+                <a:cs typeface="Calibri" pitchFamily="34" charset="-120"/>
+              </a:rPr>
+              <a:t>dự</a:t>
+            </a:r>
+            <a:r>
+              <a:rPr lang="en-US" sz="1150" dirty="0">
+                <a:solidFill>
+                  <a:srgbClr val="3C4A5C"/>
+                </a:solidFill>
+                <a:latin typeface="Calibri" pitchFamily="34" charset="0"/>
+                <a:ea typeface="Calibri" pitchFamily="34" charset="-122"/>
+                <a:cs typeface="Calibri" pitchFamily="34" charset="-120"/>
+              </a:rPr>
+              <a:t> </a:t>
+            </a:r>
+            <a:r>
+              <a:rPr lang="en-US" sz="1150" dirty="0" err="1" smtClean="0">
+                <a:solidFill>
+                  <a:srgbClr val="3C4A5C"/>
+                </a:solidFill>
+                <a:latin typeface="Calibri" pitchFamily="34" charset="0"/>
+                <a:ea typeface="Calibri" pitchFamily="34" charset="-122"/>
+                <a:cs typeface="Calibri" pitchFamily="34" charset="-120"/>
+              </a:rPr>
+              <a:t>đoán</a:t>
+            </a:r>
+            <a:r>
+              <a:rPr lang="en-US" sz="1150" dirty="0" smtClean="0">
+                <a:solidFill>
+                  <a:srgbClr val="3C4A5C"/>
+                </a:solidFill>
+                <a:latin typeface="Calibri" pitchFamily="34" charset="0"/>
+                <a:ea typeface="Calibri" pitchFamily="34" charset="-122"/>
+                <a:cs typeface="Calibri" pitchFamily="34" charset="-120"/>
+              </a:rPr>
+              <a:t> </a:t>
+            </a:r>
+            <a:r>
+              <a:rPr lang="en-US" sz="1150" dirty="0">
+                <a:solidFill>
+                  <a:srgbClr val="3C4A5C"/>
+                </a:solidFill>
+                <a:latin typeface="Calibri" pitchFamily="34" charset="0"/>
+                <a:ea typeface="Calibri" pitchFamily="34" charset="-122"/>
+                <a:cs typeface="Calibri" pitchFamily="34" charset="-120"/>
+              </a:rPr>
+              <a:t>khớp ở từng vị trí</a:t>
             </a:r>
             <a:endParaRPr lang="en-US" sz="1150" dirty="0"/>
           </a:p>
@@ -6304,6 +6469,28 @@
               <a:buChar char="•"/>
             </a:pPr>
             <a:r>
+              <a:rPr lang="en-US" sz="1150" dirty="0" err="1" smtClean="0">
+                <a:solidFill>
+                  <a:srgbClr val="3C4A5C"/>
+                </a:solidFill>
+                <a:latin typeface="Calibri" pitchFamily="34" charset="0"/>
+                <a:ea typeface="Calibri" pitchFamily="34" charset="-122"/>
+                <a:cs typeface="Calibri" pitchFamily="34" charset="-120"/>
+              </a:rPr>
+              <a:t>Điểm</a:t>
+            </a:r>
+            <a:r>
+              <a:rPr lang="en-US" sz="1150" dirty="0" smtClean="0">
+                <a:solidFill>
+                  <a:srgbClr val="3C4A5C"/>
+                </a:solidFill>
+                <a:latin typeface="Calibri" pitchFamily="34" charset="0"/>
+                <a:ea typeface="Calibri" pitchFamily="34" charset="-122"/>
+                <a:cs typeface="Calibri" pitchFamily="34" charset="-120"/>
+              </a:rPr>
+              <a:t> </a:t>
+            </a:r>
+            <a:r>
               <a:rPr lang="en-US" sz="1150" dirty="0">
                 <a:solidFill>
                   <a:srgbClr val="3C4A5C"/>
@@ -6312,31 +6499,7 @@
                 <a:ea typeface="Calibri" pitchFamily="34" charset="-122"/>
                 <a:cs typeface="Calibri" pitchFamily="34" charset="-120"/>
               </a:rPr>
-              <a:t>Top-down và bottom-up: BlazePose thuộc nhóm nào, vì sao chạy nhanh</a:t>
-            </a:r>
-            <a:endParaRPr lang="en-US" sz="1150" dirty="0"/>
-          </a:p>
-          <a:p>
-            <a:pPr marL="177800" indent="-177800">
-              <a:lnSpc>
-                <a:spcPts val="1500"/>
-              </a:lnSpc>
-              <a:spcAft>
-                <a:spcPts val="600"/>
-              </a:spcAft>
-              <a:buSzPct val="100000"/>
-              <a:buChar char="•"/>
-            </a:pPr>
-            <a:r>
-              <a:rPr lang="en-US" sz="1150" dirty="0">
-                <a:solidFill>
-                  <a:srgbClr val="3C4A5C"/>
-                </a:solidFill>
-                <a:latin typeface="Calibri" pitchFamily="34" charset="0"/>
-                <a:ea typeface="Calibri" pitchFamily="34" charset="-122"/>
-                <a:cs typeface="Calibri" pitchFamily="34" charset="-120"/>
-              </a:rPr>
-              <a:t>Điểm tin cậy của mỗi khớp và cách dùng để lọc kết quả xấu</a:t>
+              <a:t>tin cậy của mỗi khớp và cách dùng để lọc kết quả xấu</a:t>
             </a:r>
             <a:endParaRPr lang="en-US" sz="1150" dirty="0"/>
           </a:p>
@@ -7458,10 +7621,173 @@
                 <a:ea typeface="Calibri" pitchFamily="34" charset="-122"/>
                 <a:cs typeface="Calibri" pitchFamily="34" charset="-120"/>
               </a:rPr>
-              <a:t>Chuẩn hóa tỉ lệ: chia cho chiều dài thân để bất biến với khoảng cách camera</a:t>
+              <a:t>Chuẩn hóa tỉ lệ: chia cho chiều dài thân để bất biến với khoảng </a:t>
+            </a:r>
+            <a:r>
+              <a:rPr lang="en-US" sz="1150" dirty="0" err="1">
+                <a:solidFill>
+                  <a:srgbClr val="3C4A5C"/>
+                </a:solidFill>
+                <a:latin typeface="Calibri" pitchFamily="34" charset="0"/>
+                <a:ea typeface="Calibri" pitchFamily="34" charset="-122"/>
+                <a:cs typeface="Calibri" pitchFamily="34" charset="-120"/>
+              </a:rPr>
+              <a:t>cách</a:t>
+            </a:r>
+            <a:r>
+              <a:rPr lang="en-US" sz="1150" dirty="0">
+                <a:solidFill>
+                  <a:srgbClr val="3C4A5C"/>
+                </a:solidFill>
+                <a:latin typeface="Calibri" pitchFamily="34" charset="0"/>
+                <a:ea typeface="Calibri" pitchFamily="34" charset="-122"/>
+                <a:cs typeface="Calibri" pitchFamily="34" charset="-120"/>
+              </a:rPr>
+              <a:t> </a:t>
+            </a:r>
+            <a:r>
+              <a:rPr lang="en-US" sz="1150" dirty="0" smtClean="0">
+                <a:solidFill>
+                  <a:srgbClr val="3C4A5C"/>
+                </a:solidFill>
+                <a:latin typeface="Calibri" pitchFamily="34" charset="0"/>
+                <a:ea typeface="Calibri" pitchFamily="34" charset="-122"/>
+                <a:cs typeface="Calibri" pitchFamily="34" charset="-120"/>
+              </a:rPr>
+              <a:t>camera</a:t>
             </a:r>
             <a:endParaRPr lang="en-US" sz="1150" dirty="0"/>
           </a:p>
+        </p:txBody>
+      </p:sp>
+      <p:sp>
+        <p:nvSpPr>
+          <p:cNvPr id="18" name="Shape 16"/>
+          <p:cNvSpPr/>
+          <p:nvPr/>
+        </p:nvSpPr>
+        <p:spPr>
+          <a:xfrm>
+            <a:off x="4368698" y="2297430"/>
+            <a:ext cx="3454298" cy="3291840"/>
+          </a:xfrm>
+          <a:prstGeom prst="roundRect">
+            <a:avLst>
+              <a:gd name="adj" fmla="val 1667"/>
+            </a:avLst>
+          </a:prstGeom>
+          <a:solidFill>
+            <a:srgbClr val="F4F7FA"/>
+          </a:solidFill>
+          <a:ln w="9525">
+            <a:solidFill>
+              <a:srgbClr val="DDE4ED"/>
+            </a:solidFill>
+            <a:prstDash val="solid"/>
+          </a:ln>
+        </p:spPr>
+      </p:sp>
+      <p:sp>
+        <p:nvSpPr>
+          <p:cNvPr id="19" name="Text 17"/>
+          <p:cNvSpPr txBox="1"/>
+          <p:nvPr/>
+        </p:nvSpPr>
+        <p:spPr>
+          <a:xfrm>
+            <a:off x="4624730" y="2535174"/>
+            <a:ext cx="2942234" cy="201168"/>
+          </a:xfrm>
+          <a:prstGeom prst="rect">
+            <a:avLst/>
+          </a:prstGeom>
+          <a:noFill/>
+          <a:ln/>
+        </p:spPr>
+        <p:txBody>
+          <a:bodyPr wrap="square" lIns="0" tIns="0" rIns="0" bIns="0" rtlCol="0" anchor="t"/>
+          <a:lstStyle/>
+          <a:p>
+            <a:pPr marL="0" indent="0">
+              <a:buNone/>
+            </a:pPr>
+            <a:r>
+              <a:rPr lang="en-US" sz="950" b="1" kern="0" spc="130" dirty="0">
+                <a:solidFill>
+                  <a:srgbClr val="1E3A5F"/>
+                </a:solidFill>
+                <a:latin typeface="Calibri" pitchFamily="34" charset="0"/>
+                <a:ea typeface="Calibri" pitchFamily="34" charset="-122"/>
+                <a:cs typeface="Calibri" pitchFamily="34" charset="-120"/>
+              </a:rPr>
+              <a:t>THỰC HIỆN</a:t>
+            </a:r>
+            <a:endParaRPr lang="en-US" sz="950" dirty="0"/>
+          </a:p>
+        </p:txBody>
+      </p:sp>
+      <p:sp>
+        <p:nvSpPr>
+          <p:cNvPr id="20" name="Text 18"/>
+          <p:cNvSpPr txBox="1"/>
+          <p:nvPr/>
+        </p:nvSpPr>
+        <p:spPr>
+          <a:xfrm>
+            <a:off x="4624730" y="2791206"/>
+            <a:ext cx="2942234" cy="457200"/>
+          </a:xfrm>
+          <a:prstGeom prst="rect">
+            <a:avLst/>
+          </a:prstGeom>
+          <a:noFill/>
+          <a:ln/>
+        </p:spPr>
+        <p:txBody>
+          <a:bodyPr wrap="square" lIns="0" tIns="0" rIns="0" bIns="0" rtlCol="0" anchor="t"/>
+          <a:lstStyle/>
+          <a:p>
+            <a:pPr marL="0" indent="0">
+              <a:lnSpc>
+                <a:spcPts val="1700"/>
+              </a:lnSpc>
+              <a:buNone/>
+            </a:pPr>
+            <a:r>
+              <a:rPr lang="en-US" sz="1400" b="1" dirty="0">
+                <a:solidFill>
+                  <a:srgbClr val="1E3A5F"/>
+                </a:solidFill>
+                <a:latin typeface="Arial" pitchFamily="34" charset="0"/>
+                <a:ea typeface="Arial" pitchFamily="34" charset="-122"/>
+                <a:cs typeface="Arial" pitchFamily="34" charset="-120"/>
+              </a:rPr>
+              <a:t>Module tiền xử lý</a:t>
+            </a:r>
+            <a:endParaRPr lang="en-US" sz="1400" dirty="0"/>
+          </a:p>
+        </p:txBody>
+      </p:sp>
+      <p:sp>
+        <p:nvSpPr>
+          <p:cNvPr id="21" name="Text 19"/>
+          <p:cNvSpPr txBox="1"/>
+          <p:nvPr/>
+        </p:nvSpPr>
+        <p:spPr>
+          <a:xfrm>
+            <a:off x="4624730" y="3321558"/>
+            <a:ext cx="2997098" cy="2121408"/>
+          </a:xfrm>
+          <a:prstGeom prst="rect">
+            <a:avLst/>
+          </a:prstGeom>
+          <a:noFill/>
+          <a:ln/>
+        </p:spPr>
+        <p:txBody>
+          <a:bodyPr wrap="square" lIns="0" tIns="0" rIns="0" bIns="0" rtlCol="0" anchor="t"/>
+          <a:lstStyle/>
           <a:p>
             <a:pPr marL="177800" indent="-177800">
               <a:lnSpc>
@@ -7482,9 +7808,20 @@
                 <a:ea typeface="Calibri" pitchFamily="34" charset="-122"/>
                 <a:cs typeface="Calibri" pitchFamily="34" charset="-120"/>
               </a:rPr>
-              <a:t>Góc khớp tính từ ba điểm, vì sao góc ổn định hơn tọa độ</a:t>
-            </a:r>
-            <a:endParaRPr lang="en-US" sz="1150" dirty="0"/>
+              <a:t>Viết hàm chuẩn hóa 33 </a:t>
+            </a:r>
+            <a:r>
+              <a:rPr lang="en-US" sz="1150" dirty="0" err="1" smtClean="0">
+                <a:solidFill>
+                  <a:srgbClr val="3C4A5C"/>
+                </a:solidFill>
+                <a:latin typeface="Calibri" pitchFamily="34" charset="0"/>
+                <a:ea typeface="Calibri" pitchFamily="34" charset="-122"/>
+                <a:cs typeface="Calibri" pitchFamily="34" charset="-120"/>
+              </a:rPr>
+              <a:t>điểm</a:t>
+            </a:r>
+            <a:endParaRPr lang="en-US" sz="1150" dirty="0" smtClean="0"/>
           </a:p>
           <a:p>
             <a:pPr marL="177800" indent="-177800">
@@ -7498,148 +7835,304 @@
               <a:buChar char="•"/>
             </a:pPr>
             <a:r>
-              <a:rPr lang="en-US" sz="1150" dirty="0">
-                <a:solidFill>
-                  <a:srgbClr val="3C4A5C"/>
-                </a:solidFill>
-                <a:latin typeface="Calibri" pitchFamily="34" charset="0"/>
-                <a:ea typeface="Calibri" pitchFamily="34" charset="-122"/>
-                <a:cs typeface="Calibri" pitchFamily="34" charset="-120"/>
-              </a:rPr>
-              <a:t>Vận tốc khớp: sai phân giữa các khung hình liên tiếp</a:t>
-            </a:r>
-            <a:endParaRPr lang="en-US" sz="1150" dirty="0"/>
-          </a:p>
-        </p:txBody>
-      </p:sp>
-      <p:sp>
-        <p:nvSpPr>
-          <p:cNvPr id="18" name="Shape 16"/>
-          <p:cNvSpPr/>
-          <p:nvPr/>
-        </p:nvSpPr>
-        <p:spPr>
-          <a:xfrm>
-            <a:off x="4368698" y="2297430"/>
-            <a:ext cx="3454298" cy="3291840"/>
-          </a:xfrm>
-          <a:prstGeom prst="roundRect">
-            <a:avLst>
-              <a:gd name="adj" fmla="val 1667"/>
-            </a:avLst>
-          </a:prstGeom>
-          <a:solidFill>
-            <a:srgbClr val="F4F7FA"/>
-          </a:solidFill>
-          <a:ln w="9525">
-            <a:solidFill>
-              <a:srgbClr val="DDE4ED"/>
-            </a:solidFill>
-            <a:prstDash val="solid"/>
-          </a:ln>
-        </p:spPr>
-      </p:sp>
-      <p:sp>
-        <p:nvSpPr>
-          <p:cNvPr id="19" name="Text 17"/>
-          <p:cNvSpPr txBox="1"/>
-          <p:nvPr/>
-        </p:nvSpPr>
-        <p:spPr>
-          <a:xfrm>
-            <a:off x="4624730" y="2535174"/>
-            <a:ext cx="2942234" cy="201168"/>
-          </a:xfrm>
-          <a:prstGeom prst="rect">
-            <a:avLst/>
-          </a:prstGeom>
-          <a:noFill/>
-          <a:ln/>
-        </p:spPr>
-        <p:txBody>
-          <a:bodyPr wrap="square" lIns="0" tIns="0" rIns="0" bIns="0" rtlCol="0" anchor="t"/>
-          <a:lstStyle/>
-          <a:p>
-            <a:pPr marL="0" indent="0">
-              <a:buNone/>
-            </a:pPr>
-            <a:r>
-              <a:rPr lang="en-US" sz="950" b="1" kern="0" spc="130" dirty="0">
-                <a:solidFill>
-                  <a:srgbClr val="1E3A5F"/>
-                </a:solidFill>
-                <a:latin typeface="Calibri" pitchFamily="34" charset="0"/>
-                <a:ea typeface="Calibri" pitchFamily="34" charset="-122"/>
-                <a:cs typeface="Calibri" pitchFamily="34" charset="-120"/>
-              </a:rPr>
-              <a:t>THỰC HIỆN</a:t>
-            </a:r>
-            <a:endParaRPr lang="en-US" sz="950" dirty="0"/>
-          </a:p>
-        </p:txBody>
-      </p:sp>
-      <p:sp>
-        <p:nvSpPr>
-          <p:cNvPr id="20" name="Text 18"/>
-          <p:cNvSpPr txBox="1"/>
-          <p:nvPr/>
-        </p:nvSpPr>
-        <p:spPr>
-          <a:xfrm>
-            <a:off x="4624730" y="2791206"/>
-            <a:ext cx="2942234" cy="457200"/>
-          </a:xfrm>
-          <a:prstGeom prst="rect">
-            <a:avLst/>
-          </a:prstGeom>
-          <a:noFill/>
-          <a:ln/>
-        </p:spPr>
-        <p:txBody>
-          <a:bodyPr wrap="square" lIns="0" tIns="0" rIns="0" bIns="0" rtlCol="0" anchor="t"/>
-          <a:lstStyle/>
-          <a:p>
-            <a:pPr marL="0" indent="0">
-              <a:lnSpc>
-                <a:spcPts val="1700"/>
-              </a:lnSpc>
-              <a:buNone/>
-            </a:pPr>
-            <a:r>
-              <a:rPr lang="en-US" sz="1400" b="1" dirty="0">
-                <a:solidFill>
-                  <a:srgbClr val="1E3A5F"/>
-                </a:solidFill>
-                <a:latin typeface="Arial" pitchFamily="34" charset="0"/>
-                <a:ea typeface="Arial" pitchFamily="34" charset="-122"/>
-                <a:cs typeface="Arial" pitchFamily="34" charset="-120"/>
-              </a:rPr>
-              <a:t>Module tiền xử lý</a:t>
-            </a:r>
-            <a:endParaRPr lang="en-US" sz="1400" dirty="0"/>
-          </a:p>
-        </p:txBody>
-      </p:sp>
-      <p:sp>
-        <p:nvSpPr>
-          <p:cNvPr id="21" name="Text 19"/>
-          <p:cNvSpPr txBox="1"/>
-          <p:nvPr/>
-        </p:nvSpPr>
-        <p:spPr>
-          <a:xfrm>
-            <a:off x="4624730" y="3321558"/>
-            <a:ext cx="2997098" cy="2121408"/>
-          </a:xfrm>
-          <a:prstGeom prst="rect">
-            <a:avLst/>
-          </a:prstGeom>
-          <a:noFill/>
-          <a:ln/>
-        </p:spPr>
-        <p:txBody>
-          <a:bodyPr wrap="square" lIns="0" tIns="0" rIns="0" bIns="0" rtlCol="0" anchor="t"/>
-          <a:lstStyle/>
+              <a:rPr lang="en-US" sz="1150" dirty="0" err="1" smtClean="0">
+                <a:solidFill>
+                  <a:srgbClr val="3C4A5C"/>
+                </a:solidFill>
+                <a:latin typeface="Calibri" pitchFamily="34" charset="0"/>
+                <a:ea typeface="Calibri" pitchFamily="34" charset="-122"/>
+                <a:cs typeface="Calibri" pitchFamily="34" charset="-120"/>
+              </a:rPr>
+              <a:t>Viết</a:t>
+            </a:r>
+            <a:r>
+              <a:rPr lang="en-US" sz="1150" dirty="0" smtClean="0">
+                <a:solidFill>
+                  <a:srgbClr val="3C4A5C"/>
+                </a:solidFill>
+                <a:latin typeface="Calibri" pitchFamily="34" charset="0"/>
+                <a:ea typeface="Calibri" pitchFamily="34" charset="-122"/>
+                <a:cs typeface="Calibri" pitchFamily="34" charset="-120"/>
+              </a:rPr>
+              <a:t> </a:t>
+            </a:r>
+            <a:r>
+              <a:rPr lang="en-US" sz="1150" dirty="0" err="1" smtClean="0">
+                <a:solidFill>
+                  <a:srgbClr val="3C4A5C"/>
+                </a:solidFill>
+                <a:latin typeface="Calibri" pitchFamily="34" charset="0"/>
+                <a:ea typeface="Calibri" pitchFamily="34" charset="-122"/>
+                <a:cs typeface="Calibri" pitchFamily="34" charset="-120"/>
+              </a:rPr>
+              <a:t>hàm</a:t>
+            </a:r>
+            <a:r>
+              <a:rPr lang="en-US" sz="1150" dirty="0" smtClean="0">
+                <a:solidFill>
+                  <a:srgbClr val="3C4A5C"/>
+                </a:solidFill>
+                <a:latin typeface="Calibri" pitchFamily="34" charset="0"/>
+                <a:ea typeface="Calibri" pitchFamily="34" charset="-122"/>
+                <a:cs typeface="Calibri" pitchFamily="34" charset="-120"/>
+              </a:rPr>
+              <a:t> </a:t>
+            </a:r>
+            <a:r>
+              <a:rPr lang="en-US" sz="1150" dirty="0" err="1" smtClean="0">
+                <a:solidFill>
+                  <a:srgbClr val="3C4A5C"/>
+                </a:solidFill>
+                <a:latin typeface="Calibri" pitchFamily="34" charset="0"/>
+                <a:ea typeface="Calibri" pitchFamily="34" charset="-122"/>
+                <a:cs typeface="Calibri" pitchFamily="34" charset="-120"/>
+              </a:rPr>
+              <a:t>tính</a:t>
+            </a:r>
+            <a:r>
+              <a:rPr lang="en-US" sz="1150" dirty="0" smtClean="0">
+                <a:solidFill>
+                  <a:srgbClr val="3C4A5C"/>
+                </a:solidFill>
+                <a:latin typeface="Calibri" pitchFamily="34" charset="0"/>
+                <a:ea typeface="Calibri" pitchFamily="34" charset="-122"/>
+                <a:cs typeface="Calibri" pitchFamily="34" charset="-120"/>
+              </a:rPr>
+              <a:t> </a:t>
+            </a:r>
+            <a:r>
+              <a:rPr lang="en-US" sz="1150" dirty="0" err="1" smtClean="0">
+                <a:solidFill>
+                  <a:srgbClr val="3C4A5C"/>
+                </a:solidFill>
+                <a:latin typeface="Calibri" pitchFamily="34" charset="0"/>
+                <a:ea typeface="Calibri" pitchFamily="34" charset="-122"/>
+                <a:cs typeface="Calibri" pitchFamily="34" charset="-120"/>
+              </a:rPr>
+              <a:t>góc</a:t>
+            </a:r>
+            <a:r>
+              <a:rPr lang="en-US" sz="1150" dirty="0" smtClean="0">
+                <a:solidFill>
+                  <a:srgbClr val="3C4A5C"/>
+                </a:solidFill>
+                <a:latin typeface="Calibri" pitchFamily="34" charset="0"/>
+                <a:ea typeface="Calibri" pitchFamily="34" charset="-122"/>
+                <a:cs typeface="Calibri" pitchFamily="34" charset="-120"/>
+              </a:rPr>
+              <a:t> </a:t>
+            </a:r>
+            <a:r>
+              <a:rPr lang="en-US" sz="1150" dirty="0" err="1" smtClean="0">
+                <a:solidFill>
+                  <a:srgbClr val="3C4A5C"/>
+                </a:solidFill>
+                <a:latin typeface="Calibri" pitchFamily="34" charset="0"/>
+                <a:ea typeface="Calibri" pitchFamily="34" charset="-122"/>
+                <a:cs typeface="Calibri" pitchFamily="34" charset="-120"/>
+              </a:rPr>
+              <a:t>khuỷu</a:t>
+            </a:r>
+            <a:r>
+              <a:rPr lang="en-US" sz="1150" dirty="0" smtClean="0">
+                <a:solidFill>
+                  <a:srgbClr val="3C4A5C"/>
+                </a:solidFill>
+                <a:latin typeface="Calibri" pitchFamily="34" charset="0"/>
+                <a:ea typeface="Calibri" pitchFamily="34" charset="-122"/>
+                <a:cs typeface="Calibri" pitchFamily="34" charset="-120"/>
+              </a:rPr>
+              <a:t>, </a:t>
+            </a:r>
+            <a:r>
+              <a:rPr lang="en-US" sz="1150" dirty="0" err="1" smtClean="0">
+                <a:solidFill>
+                  <a:srgbClr val="3C4A5C"/>
+                </a:solidFill>
+                <a:latin typeface="Calibri" pitchFamily="34" charset="0"/>
+                <a:ea typeface="Calibri" pitchFamily="34" charset="-122"/>
+                <a:cs typeface="Calibri" pitchFamily="34" charset="-120"/>
+              </a:rPr>
+              <a:t>gối</a:t>
+            </a:r>
+            <a:r>
+              <a:rPr lang="en-US" sz="1150" dirty="0" smtClean="0">
+                <a:solidFill>
+                  <a:srgbClr val="3C4A5C"/>
+                </a:solidFill>
+                <a:latin typeface="Calibri" pitchFamily="34" charset="0"/>
+                <a:ea typeface="Calibri" pitchFamily="34" charset="-122"/>
+                <a:cs typeface="Calibri" pitchFamily="34" charset="-120"/>
+              </a:rPr>
+              <a:t>, </a:t>
+            </a:r>
+            <a:r>
+              <a:rPr lang="en-US" sz="1150" dirty="0" err="1" smtClean="0">
+                <a:solidFill>
+                  <a:srgbClr val="3C4A5C"/>
+                </a:solidFill>
+                <a:latin typeface="Calibri" pitchFamily="34" charset="0"/>
+                <a:ea typeface="Calibri" pitchFamily="34" charset="-122"/>
+                <a:cs typeface="Calibri" pitchFamily="34" charset="-120"/>
+              </a:rPr>
+              <a:t>hông</a:t>
+            </a:r>
+            <a:r>
+              <a:rPr lang="en-US" sz="1150" dirty="0" smtClean="0">
+                <a:solidFill>
+                  <a:srgbClr val="3C4A5C"/>
+                </a:solidFill>
+                <a:latin typeface="Calibri" pitchFamily="34" charset="0"/>
+                <a:ea typeface="Calibri" pitchFamily="34" charset="-122"/>
+                <a:cs typeface="Calibri" pitchFamily="34" charset="-120"/>
+              </a:rPr>
+              <a:t> </a:t>
+            </a:r>
+            <a:r>
+              <a:rPr lang="en-US" sz="1150" dirty="0" err="1" smtClean="0">
+                <a:solidFill>
+                  <a:srgbClr val="3C4A5C"/>
+                </a:solidFill>
+                <a:latin typeface="Calibri" pitchFamily="34" charset="0"/>
+                <a:ea typeface="Calibri" pitchFamily="34" charset="-122"/>
+                <a:cs typeface="Calibri" pitchFamily="34" charset="-120"/>
+              </a:rPr>
+              <a:t>và</a:t>
+            </a:r>
+            <a:r>
+              <a:rPr lang="en-US" sz="1150" dirty="0" smtClean="0">
+                <a:solidFill>
+                  <a:srgbClr val="3C4A5C"/>
+                </a:solidFill>
+                <a:latin typeface="Calibri" pitchFamily="34" charset="0"/>
+                <a:ea typeface="Calibri" pitchFamily="34" charset="-122"/>
+                <a:cs typeface="Calibri" pitchFamily="34" charset="-120"/>
+              </a:rPr>
+              <a:t> </a:t>
+            </a:r>
+            <a:r>
+              <a:rPr lang="en-US" sz="1150" dirty="0" err="1" smtClean="0">
+                <a:solidFill>
+                  <a:srgbClr val="3C4A5C"/>
+                </a:solidFill>
+                <a:latin typeface="Calibri" pitchFamily="34" charset="0"/>
+                <a:ea typeface="Calibri" pitchFamily="34" charset="-122"/>
+                <a:cs typeface="Calibri" pitchFamily="34" charset="-120"/>
+              </a:rPr>
+              <a:t>vận</a:t>
+            </a:r>
+            <a:r>
+              <a:rPr lang="en-US" sz="1150" dirty="0" smtClean="0">
+                <a:solidFill>
+                  <a:srgbClr val="3C4A5C"/>
+                </a:solidFill>
+                <a:latin typeface="Calibri" pitchFamily="34" charset="0"/>
+                <a:ea typeface="Calibri" pitchFamily="34" charset="-122"/>
+                <a:cs typeface="Calibri" pitchFamily="34" charset="-120"/>
+              </a:rPr>
+              <a:t> </a:t>
+            </a:r>
+            <a:r>
+              <a:rPr lang="en-US" sz="1150" dirty="0" err="1" smtClean="0">
+                <a:solidFill>
+                  <a:srgbClr val="3C4A5C"/>
+                </a:solidFill>
+                <a:latin typeface="Calibri" pitchFamily="34" charset="0"/>
+                <a:ea typeface="Calibri" pitchFamily="34" charset="-122"/>
+                <a:cs typeface="Calibri" pitchFamily="34" charset="-120"/>
+              </a:rPr>
+              <a:t>tốc</a:t>
+            </a:r>
+            <a:r>
+              <a:rPr lang="en-US" sz="1150" dirty="0" smtClean="0">
+                <a:solidFill>
+                  <a:srgbClr val="3C4A5C"/>
+                </a:solidFill>
+                <a:latin typeface="Calibri" pitchFamily="34" charset="0"/>
+                <a:ea typeface="Calibri" pitchFamily="34" charset="-122"/>
+                <a:cs typeface="Calibri" pitchFamily="34" charset="-120"/>
+              </a:rPr>
+              <a:t> </a:t>
+            </a:r>
+            <a:r>
+              <a:rPr lang="en-US" sz="1150" dirty="0" err="1" smtClean="0">
+                <a:solidFill>
+                  <a:srgbClr val="3C4A5C"/>
+                </a:solidFill>
+                <a:latin typeface="Calibri" pitchFamily="34" charset="0"/>
+                <a:ea typeface="Calibri" pitchFamily="34" charset="-122"/>
+                <a:cs typeface="Calibri" pitchFamily="34" charset="-120"/>
+              </a:rPr>
+              <a:t>cổ</a:t>
+            </a:r>
+            <a:r>
+              <a:rPr lang="en-US" sz="1150" dirty="0" smtClean="0">
+                <a:solidFill>
+                  <a:srgbClr val="3C4A5C"/>
+                </a:solidFill>
+                <a:latin typeface="Calibri" pitchFamily="34" charset="0"/>
+                <a:ea typeface="Calibri" pitchFamily="34" charset="-122"/>
+                <a:cs typeface="Calibri" pitchFamily="34" charset="-120"/>
+              </a:rPr>
+              <a:t> </a:t>
+            </a:r>
+            <a:r>
+              <a:rPr lang="en-US" sz="1150" dirty="0" err="1" smtClean="0">
+                <a:solidFill>
+                  <a:srgbClr val="3C4A5C"/>
+                </a:solidFill>
+                <a:latin typeface="Calibri" pitchFamily="34" charset="0"/>
+                <a:ea typeface="Calibri" pitchFamily="34" charset="-122"/>
+                <a:cs typeface="Calibri" pitchFamily="34" charset="-120"/>
+              </a:rPr>
+              <a:t>tay</a:t>
+            </a:r>
+            <a:r>
+              <a:rPr lang="en-US" sz="1150" dirty="0" smtClean="0">
+                <a:solidFill>
+                  <a:srgbClr val="3C4A5C"/>
+                </a:solidFill>
+                <a:latin typeface="Calibri" pitchFamily="34" charset="0"/>
+                <a:ea typeface="Calibri" pitchFamily="34" charset="-122"/>
+                <a:cs typeface="Calibri" pitchFamily="34" charset="-120"/>
+              </a:rPr>
+              <a:t>, </a:t>
+            </a:r>
+            <a:r>
+              <a:rPr lang="en-US" sz="1150" dirty="0" err="1" smtClean="0">
+                <a:solidFill>
+                  <a:srgbClr val="3C4A5C"/>
+                </a:solidFill>
+                <a:latin typeface="Calibri" pitchFamily="34" charset="0"/>
+                <a:ea typeface="Calibri" pitchFamily="34" charset="-122"/>
+                <a:cs typeface="Calibri" pitchFamily="34" charset="-120"/>
+              </a:rPr>
+              <a:t>mắt</a:t>
+            </a:r>
+            <a:r>
+              <a:rPr lang="en-US" sz="1150" dirty="0" smtClean="0">
+                <a:solidFill>
+                  <a:srgbClr val="3C4A5C"/>
+                </a:solidFill>
+                <a:latin typeface="Calibri" pitchFamily="34" charset="0"/>
+                <a:ea typeface="Calibri" pitchFamily="34" charset="-122"/>
+                <a:cs typeface="Calibri" pitchFamily="34" charset="-120"/>
+              </a:rPr>
+              <a:t> </a:t>
+            </a:r>
+            <a:r>
+              <a:rPr lang="en-US" sz="1150" dirty="0" err="1" smtClean="0">
+                <a:solidFill>
+                  <a:srgbClr val="3C4A5C"/>
+                </a:solidFill>
+                <a:latin typeface="Calibri" pitchFamily="34" charset="0"/>
+                <a:ea typeface="Calibri" pitchFamily="34" charset="-122"/>
+                <a:cs typeface="Calibri" pitchFamily="34" charset="-120"/>
+              </a:rPr>
+              <a:t>cá</a:t>
+            </a:r>
+            <a:endParaRPr lang="en-US" sz="1150" dirty="0" smtClean="0"/>
+          </a:p>
           <a:p>
             <a:pPr marL="177800" indent="-177800">
               <a:lnSpc>
@@ -7652,6 +8145,28 @@
               <a:buChar char="•"/>
             </a:pPr>
             <a:r>
+              <a:rPr lang="en-US" sz="1150" dirty="0" err="1" smtClean="0">
+                <a:solidFill>
+                  <a:srgbClr val="3C4A5C"/>
+                </a:solidFill>
+                <a:latin typeface="Calibri" pitchFamily="34" charset="0"/>
+                <a:ea typeface="Calibri" pitchFamily="34" charset="-122"/>
+                <a:cs typeface="Calibri" pitchFamily="34" charset="-120"/>
+              </a:rPr>
+              <a:t>Kiểm</a:t>
+            </a:r>
+            <a:r>
+              <a:rPr lang="en-US" sz="1150" dirty="0" smtClean="0">
+                <a:solidFill>
+                  <a:srgbClr val="3C4A5C"/>
+                </a:solidFill>
+                <a:latin typeface="Calibri" pitchFamily="34" charset="0"/>
+                <a:ea typeface="Calibri" pitchFamily="34" charset="-122"/>
+                <a:cs typeface="Calibri" pitchFamily="34" charset="-120"/>
+              </a:rPr>
+              <a:t> </a:t>
+            </a:r>
+            <a:r>
               <a:rPr lang="en-US" sz="1150" dirty="0">
                 <a:solidFill>
                   <a:srgbClr val="3C4A5C"/>
@@ -7660,7 +8175,7 @@
                 <a:ea typeface="Calibri" pitchFamily="34" charset="-122"/>
                 <a:cs typeface="Calibri" pitchFamily="34" charset="-120"/>
               </a:rPr>
-              <a:t>Viết hàm chuẩn hóa 33 điểm, bỏ 10 điểm trên mặt vì nhiễu</a:t>
+              <a:t>chứng: cùng tư thế đứng gần và đứng xa phải cho vector gần như nhau</a:t>
             </a:r>
             <a:endParaRPr lang="en-US" sz="1150" dirty="0"/>
           </a:p>
@@ -7684,10 +8199,140 @@
                 <a:ea typeface="Calibri" pitchFamily="34" charset="-122"/>
                 <a:cs typeface="Calibri" pitchFamily="34" charset="-120"/>
               </a:rPr>
-              <a:t>Viết hàm tính góc khuỷu, gối, hông và vận tốc cổ tay, mắt cá</a:t>
+              <a:t>Vẽ đồ thị chiều cao hông theo thời gian cho động tác ngồi xuống</a:t>
             </a:r>
             <a:endParaRPr lang="en-US" sz="1150" dirty="0"/>
           </a:p>
+        </p:txBody>
+      </p:sp>
+      <p:sp>
+        <p:nvSpPr>
+          <p:cNvPr id="22" name="Shape 20"/>
+          <p:cNvSpPr/>
+          <p:nvPr/>
+        </p:nvSpPr>
+        <p:spPr>
+          <a:xfrm>
+            <a:off x="8097317" y="2297430"/>
+            <a:ext cx="3454298" cy="3291840"/>
+          </a:xfrm>
+          <a:prstGeom prst="roundRect">
+            <a:avLst>
+              <a:gd name="adj" fmla="val 1667"/>
+            </a:avLst>
+          </a:prstGeom>
+          <a:solidFill>
+            <a:srgbClr val="FFFFFF"/>
+          </a:solidFill>
+          <a:ln w="9525">
+            <a:solidFill>
+              <a:srgbClr val="00A88F"/>
+            </a:solidFill>
+            <a:prstDash val="solid"/>
+          </a:ln>
+        </p:spPr>
+      </p:sp>
+      <p:sp>
+        <p:nvSpPr>
+          <p:cNvPr id="23" name="Text 21"/>
+          <p:cNvSpPr txBox="1"/>
+          <p:nvPr/>
+        </p:nvSpPr>
+        <p:spPr>
+          <a:xfrm>
+            <a:off x="8353349" y="2535174"/>
+            <a:ext cx="2942234" cy="201168"/>
+          </a:xfrm>
+          <a:prstGeom prst="rect">
+            <a:avLst/>
+          </a:prstGeom>
+          <a:noFill/>
+          <a:ln/>
+        </p:spPr>
+        <p:txBody>
+          <a:bodyPr wrap="square" lIns="0" tIns="0" rIns="0" bIns="0" rtlCol="0" anchor="t"/>
+          <a:lstStyle/>
+          <a:p>
+            <a:pPr marL="0" indent="0">
+              <a:buNone/>
+            </a:pPr>
+            <a:r>
+              <a:rPr lang="en-US" sz="950" b="1" kern="0" spc="130" dirty="0" smtClean="0">
+                <a:solidFill>
+                  <a:srgbClr val="00806D"/>
+                </a:solidFill>
+                <a:latin typeface="Calibri" pitchFamily="34" charset="0"/>
+                <a:ea typeface="Calibri" pitchFamily="34" charset="-122"/>
+                <a:cs typeface="Calibri" pitchFamily="34" charset="-120"/>
+              </a:rPr>
+              <a:t>MỤC TIÊU</a:t>
+            </a:r>
+            <a:endParaRPr lang="en-US" sz="950" dirty="0"/>
+          </a:p>
+        </p:txBody>
+      </p:sp>
+      <p:sp>
+        <p:nvSpPr>
+          <p:cNvPr id="24" name="Text 22"/>
+          <p:cNvSpPr txBox="1"/>
+          <p:nvPr/>
+        </p:nvSpPr>
+        <p:spPr>
+          <a:xfrm>
+            <a:off x="8353349" y="2791206"/>
+            <a:ext cx="2942234" cy="457200"/>
+          </a:xfrm>
+          <a:prstGeom prst="rect">
+            <a:avLst/>
+          </a:prstGeom>
+          <a:noFill/>
+          <a:ln/>
+        </p:spPr>
+        <p:txBody>
+          <a:bodyPr wrap="square" lIns="0" tIns="0" rIns="0" bIns="0" rtlCol="0" anchor="t"/>
+          <a:lstStyle/>
+          <a:p>
+            <a:pPr marL="0" indent="0">
+              <a:lnSpc>
+                <a:spcPts val="1700"/>
+              </a:lnSpc>
+              <a:buNone/>
+            </a:pPr>
+            <a:r>
+              <a:rPr lang="en-US" sz="1400" b="1" dirty="0">
+                <a:solidFill>
+                  <a:srgbClr val="1E3A5F"/>
+                </a:solidFill>
+                <a:latin typeface="Arial" pitchFamily="34" charset="0"/>
+                <a:ea typeface="Arial" pitchFamily="34" charset="-122"/>
+                <a:cs typeface="Arial" pitchFamily="34" charset="-120"/>
+              </a:rPr>
+              <a:t>Sản phẩm ngày 08/10</a:t>
+            </a:r>
+            <a:endParaRPr lang="en-US" sz="1400" dirty="0"/>
+          </a:p>
+        </p:txBody>
+      </p:sp>
+      <p:sp>
+        <p:nvSpPr>
+          <p:cNvPr id="25" name="Text 23"/>
+          <p:cNvSpPr txBox="1"/>
+          <p:nvPr/>
+        </p:nvSpPr>
+        <p:spPr>
+          <a:xfrm>
+            <a:off x="8353349" y="3321558"/>
+            <a:ext cx="2997098" cy="2121408"/>
+          </a:xfrm>
+          <a:prstGeom prst="rect">
+            <a:avLst/>
+          </a:prstGeom>
+          <a:noFill/>
+          <a:ln/>
+        </p:spPr>
+        <p:txBody>
+          <a:bodyPr wrap="square" lIns="0" tIns="0" rIns="0" bIns="0" rtlCol="0" anchor="t"/>
+          <a:lstStyle/>
           <a:p>
             <a:pPr marL="177800" indent="-177800">
               <a:lnSpc>
@@ -7708,21 +8353,19 @@
                 <a:ea typeface="Calibri" pitchFamily="34" charset="-122"/>
                 <a:cs typeface="Calibri" pitchFamily="34" charset="-120"/>
               </a:rPr>
-              <a:t>Kiểm chứng: cùng tư thế đứng gần và đứng xa phải cho vector gần như nhau</a:t>
-            </a:r>
-            <a:endParaRPr lang="en-US" sz="1150" dirty="0"/>
-          </a:p>
-          <a:p>
-            <a:pPr marL="177800" indent="-177800">
-              <a:lnSpc>
-                <a:spcPts val="1500"/>
-              </a:lnSpc>
-              <a:spcAft>
-                <a:spcPts val="600"/>
-              </a:spcAft>
-              <a:buSzPct val="100000"/>
-              <a:buChar char="•"/>
-            </a:pPr>
+              <a:t>Module tiền xử lý chạy được, có thể tái </a:t>
+            </a:r>
+            <a:r>
+              <a:rPr lang="en-US" sz="1150" dirty="0" err="1">
+                <a:solidFill>
+                  <a:srgbClr val="3C4A5C"/>
+                </a:solidFill>
+                <a:latin typeface="Calibri" pitchFamily="34" charset="0"/>
+                <a:ea typeface="Calibri" pitchFamily="34" charset="-122"/>
+                <a:cs typeface="Calibri" pitchFamily="34" charset="-120"/>
+              </a:rPr>
+              <a:t>sử</a:t>
+            </a:r>
             <a:r>
               <a:rPr lang="en-US" sz="1150" dirty="0">
                 <a:solidFill>
@@ -7732,185 +8375,18 @@
                 <a:ea typeface="Calibri" pitchFamily="34" charset="-122"/>
                 <a:cs typeface="Calibri" pitchFamily="34" charset="-120"/>
               </a:rPr>
-              <a:t>Vẽ đồ thị chiều cao hông theo thời gian cho động tác ngồi xuống</a:t>
-            </a:r>
-            <a:endParaRPr lang="en-US" sz="1150" dirty="0"/>
-          </a:p>
-        </p:txBody>
-      </p:sp>
-      <p:sp>
-        <p:nvSpPr>
-          <p:cNvPr id="22" name="Shape 20"/>
-          <p:cNvSpPr/>
-          <p:nvPr/>
-        </p:nvSpPr>
-        <p:spPr>
-          <a:xfrm>
-            <a:off x="8097317" y="2297430"/>
-            <a:ext cx="3454298" cy="3291840"/>
-          </a:xfrm>
-          <a:prstGeom prst="roundRect">
-            <a:avLst>
-              <a:gd name="adj" fmla="val 1667"/>
-            </a:avLst>
-          </a:prstGeom>
-          <a:solidFill>
-            <a:srgbClr val="FFFFFF"/>
-          </a:solidFill>
-          <a:ln w="9525">
-            <a:solidFill>
-              <a:srgbClr val="00A88F"/>
-            </a:solidFill>
-            <a:prstDash val="solid"/>
-          </a:ln>
-        </p:spPr>
-      </p:sp>
-      <p:sp>
-        <p:nvSpPr>
-          <p:cNvPr id="23" name="Text 21"/>
-          <p:cNvSpPr txBox="1"/>
-          <p:nvPr/>
-        </p:nvSpPr>
-        <p:spPr>
-          <a:xfrm>
-            <a:off x="8353349" y="2535174"/>
-            <a:ext cx="2942234" cy="201168"/>
-          </a:xfrm>
-          <a:prstGeom prst="rect">
-            <a:avLst/>
-          </a:prstGeom>
-          <a:noFill/>
-          <a:ln/>
-        </p:spPr>
-        <p:txBody>
-          <a:bodyPr wrap="square" lIns="0" tIns="0" rIns="0" bIns="0" rtlCol="0" anchor="t"/>
-          <a:lstStyle/>
-          <a:p>
-            <a:pPr marL="0" indent="0">
-              <a:buNone/>
-            </a:pPr>
-            <a:r>
-              <a:rPr lang="en-US" sz="950" b="1" kern="0" spc="130" dirty="0" smtClean="0">
-                <a:solidFill>
-                  <a:srgbClr val="00806D"/>
-                </a:solidFill>
-                <a:latin typeface="Calibri" pitchFamily="34" charset="0"/>
-                <a:ea typeface="Calibri" pitchFamily="34" charset="-122"/>
-                <a:cs typeface="Calibri" pitchFamily="34" charset="-120"/>
-              </a:rPr>
-              <a:t>MỤC TIÊU</a:t>
-            </a:r>
-            <a:endParaRPr lang="en-US" sz="950" dirty="0"/>
-          </a:p>
-        </p:txBody>
-      </p:sp>
-      <p:sp>
-        <p:nvSpPr>
-          <p:cNvPr id="24" name="Text 22"/>
-          <p:cNvSpPr txBox="1"/>
-          <p:nvPr/>
-        </p:nvSpPr>
-        <p:spPr>
-          <a:xfrm>
-            <a:off x="8353349" y="2791206"/>
-            <a:ext cx="2942234" cy="457200"/>
-          </a:xfrm>
-          <a:prstGeom prst="rect">
-            <a:avLst/>
-          </a:prstGeom>
-          <a:noFill/>
-          <a:ln/>
-        </p:spPr>
-        <p:txBody>
-          <a:bodyPr wrap="square" lIns="0" tIns="0" rIns="0" bIns="0" rtlCol="0" anchor="t"/>
-          <a:lstStyle/>
-          <a:p>
-            <a:pPr marL="0" indent="0">
-              <a:lnSpc>
-                <a:spcPts val="1700"/>
-              </a:lnSpc>
-              <a:buNone/>
-            </a:pPr>
-            <a:r>
-              <a:rPr lang="en-US" sz="1400" b="1" dirty="0">
-                <a:solidFill>
-                  <a:srgbClr val="1E3A5F"/>
-                </a:solidFill>
-                <a:latin typeface="Arial" pitchFamily="34" charset="0"/>
-                <a:ea typeface="Arial" pitchFamily="34" charset="-122"/>
-                <a:cs typeface="Arial" pitchFamily="34" charset="-120"/>
-              </a:rPr>
-              <a:t>Sản phẩm ngày 08/10</a:t>
-            </a:r>
-            <a:endParaRPr lang="en-US" sz="1400" dirty="0"/>
-          </a:p>
-        </p:txBody>
-      </p:sp>
-      <p:sp>
-        <p:nvSpPr>
-          <p:cNvPr id="25" name="Text 23"/>
-          <p:cNvSpPr txBox="1"/>
-          <p:nvPr/>
-        </p:nvSpPr>
-        <p:spPr>
-          <a:xfrm>
-            <a:off x="8353349" y="3321558"/>
-            <a:ext cx="2997098" cy="2121408"/>
-          </a:xfrm>
-          <a:prstGeom prst="rect">
-            <a:avLst/>
-          </a:prstGeom>
-          <a:noFill/>
-          <a:ln/>
-        </p:spPr>
-        <p:txBody>
-          <a:bodyPr wrap="square" lIns="0" tIns="0" rIns="0" bIns="0" rtlCol="0" anchor="t"/>
-          <a:lstStyle/>
-          <a:p>
-            <a:pPr marL="177800" indent="-177800">
-              <a:lnSpc>
-                <a:spcPts val="1500"/>
-              </a:lnSpc>
-              <a:spcAft>
-                <a:spcPts val="600"/>
-              </a:spcAft>
-              <a:buSzPct val="100000"/>
-              <a:buChar char="•"/>
-            </a:pPr>
-            <a:r>
-              <a:rPr lang="en-US" sz="1150" dirty="0">
-                <a:solidFill>
-                  <a:srgbClr val="3C4A5C"/>
-                </a:solidFill>
-                <a:latin typeface="Calibri" pitchFamily="34" charset="0"/>
-                <a:ea typeface="Calibri" pitchFamily="34" charset="-122"/>
-                <a:cs typeface="Calibri" pitchFamily="34" charset="-120"/>
-              </a:rPr>
-              <a:t>Module tiền xử lý chạy được, có thể tái sử dụng</a:t>
-            </a:r>
-            <a:endParaRPr lang="en-US" sz="1150" dirty="0"/>
-          </a:p>
-          <a:p>
-            <a:pPr marL="177800" indent="-177800">
-              <a:lnSpc>
-                <a:spcPts val="1500"/>
-              </a:lnSpc>
-              <a:spcAft>
-                <a:spcPts val="600"/>
-              </a:spcAft>
-              <a:buSzPct val="100000"/>
-              <a:buChar char="•"/>
-            </a:pPr>
-            <a:r>
-              <a:rPr lang="en-US" sz="1150" dirty="0">
-                <a:solidFill>
-                  <a:srgbClr val="3C4A5C"/>
-                </a:solidFill>
-                <a:latin typeface="Calibri" pitchFamily="34" charset="0"/>
-                <a:ea typeface="Calibri" pitchFamily="34" charset="-122"/>
-                <a:cs typeface="Calibri" pitchFamily="34" charset="-120"/>
-              </a:rPr>
-              <a:t>Bằng chứng chuẩn hóa đúng: bảng so sánh vector ở hai khoảng cách</a:t>
+              <a:t> </a:t>
+            </a:r>
+            <a:r>
+              <a:rPr lang="en-US" sz="1150" dirty="0" err="1" smtClean="0">
+                <a:solidFill>
+                  <a:srgbClr val="3C4A5C"/>
+                </a:solidFill>
+                <a:latin typeface="Calibri" pitchFamily="34" charset="0"/>
+                <a:ea typeface="Calibri" pitchFamily="34" charset="-122"/>
+                <a:cs typeface="Calibri" pitchFamily="34" charset="-120"/>
+              </a:rPr>
+              <a:t>dụng</a:t>
             </a:r>
             <a:endParaRPr lang="en-US" sz="1150" dirty="0"/>
           </a:p>
@@ -8613,6 +9089,28 @@
               <a:buChar char="•"/>
             </a:pPr>
             <a:r>
+              <a:rPr lang="en-US" sz="1150" dirty="0" err="1" smtClean="0">
+                <a:solidFill>
+                  <a:srgbClr val="3C4A5C"/>
+                </a:solidFill>
+                <a:latin typeface="Calibri" pitchFamily="34" charset="0"/>
+                <a:ea typeface="Calibri" pitchFamily="34" charset="-122"/>
+                <a:cs typeface="Calibri" pitchFamily="34" charset="-120"/>
+              </a:rPr>
+              <a:t>Rò</a:t>
+            </a:r>
+            <a:r>
+              <a:rPr lang="en-US" sz="1150" dirty="0" smtClean="0">
+                <a:solidFill>
+                  <a:srgbClr val="3C4A5C"/>
+                </a:solidFill>
+                <a:latin typeface="Calibri" pitchFamily="34" charset="0"/>
+                <a:ea typeface="Calibri" pitchFamily="34" charset="-122"/>
+                <a:cs typeface="Calibri" pitchFamily="34" charset="-120"/>
+              </a:rPr>
+              <a:t> </a:t>
+            </a:r>
+            <a:r>
               <a:rPr lang="en-US" sz="1150" dirty="0">
                 <a:solidFill>
                   <a:srgbClr val="3C4A5C"/>
@@ -8621,10 +9119,173 @@
                 <a:ea typeface="Calibri" pitchFamily="34" charset="-122"/>
                 <a:cs typeface="Calibri" pitchFamily="34" charset="-120"/>
               </a:rPr>
-              <a:t>Precision và recall từng lớp, vì sao recall của "ngã" quan trọng nhất</a:t>
+              <a:t>rỉ dữ liệu: chia tập theo khung hình so với chia </a:t>
+            </a:r>
+            <a:r>
+              <a:rPr lang="en-US" sz="1150" dirty="0" err="1">
+                <a:solidFill>
+                  <a:srgbClr val="3C4A5C"/>
+                </a:solidFill>
+                <a:latin typeface="Calibri" pitchFamily="34" charset="0"/>
+                <a:ea typeface="Calibri" pitchFamily="34" charset="-122"/>
+                <a:cs typeface="Calibri" pitchFamily="34" charset="-120"/>
+              </a:rPr>
+              <a:t>theo</a:t>
+            </a:r>
+            <a:r>
+              <a:rPr lang="en-US" sz="1150" dirty="0">
+                <a:solidFill>
+                  <a:srgbClr val="3C4A5C"/>
+                </a:solidFill>
+                <a:latin typeface="Calibri" pitchFamily="34" charset="0"/>
+                <a:ea typeface="Calibri" pitchFamily="34" charset="-122"/>
+                <a:cs typeface="Calibri" pitchFamily="34" charset="-120"/>
+              </a:rPr>
+              <a:t> </a:t>
+            </a:r>
+            <a:r>
+              <a:rPr lang="en-US" sz="1150" dirty="0" err="1" smtClean="0">
+                <a:solidFill>
+                  <a:srgbClr val="3C4A5C"/>
+                </a:solidFill>
+                <a:latin typeface="Calibri" pitchFamily="34" charset="0"/>
+                <a:ea typeface="Calibri" pitchFamily="34" charset="-122"/>
+                <a:cs typeface="Calibri" pitchFamily="34" charset="-120"/>
+              </a:rPr>
+              <a:t>người</a:t>
             </a:r>
             <a:endParaRPr lang="en-US" sz="1150" dirty="0"/>
           </a:p>
+        </p:txBody>
+      </p:sp>
+      <p:sp>
+        <p:nvSpPr>
+          <p:cNvPr id="18" name="Shape 16"/>
+          <p:cNvSpPr/>
+          <p:nvPr/>
+        </p:nvSpPr>
+        <p:spPr>
+          <a:xfrm>
+            <a:off x="4368698" y="2281101"/>
+            <a:ext cx="3454298" cy="3291840"/>
+          </a:xfrm>
+          <a:prstGeom prst="roundRect">
+            <a:avLst>
+              <a:gd name="adj" fmla="val 1667"/>
+            </a:avLst>
+          </a:prstGeom>
+          <a:solidFill>
+            <a:srgbClr val="F4F7FA"/>
+          </a:solidFill>
+          <a:ln w="9525">
+            <a:solidFill>
+              <a:srgbClr val="DDE4ED"/>
+            </a:solidFill>
+            <a:prstDash val="solid"/>
+          </a:ln>
+        </p:spPr>
+      </p:sp>
+      <p:sp>
+        <p:nvSpPr>
+          <p:cNvPr id="19" name="Text 17"/>
+          <p:cNvSpPr txBox="1"/>
+          <p:nvPr/>
+        </p:nvSpPr>
+        <p:spPr>
+          <a:xfrm>
+            <a:off x="4624730" y="2518845"/>
+            <a:ext cx="2942234" cy="201168"/>
+          </a:xfrm>
+          <a:prstGeom prst="rect">
+            <a:avLst/>
+          </a:prstGeom>
+          <a:noFill/>
+          <a:ln/>
+        </p:spPr>
+        <p:txBody>
+          <a:bodyPr wrap="square" lIns="0" tIns="0" rIns="0" bIns="0" rtlCol="0" anchor="t"/>
+          <a:lstStyle/>
+          <a:p>
+            <a:pPr marL="0" indent="0">
+              <a:buNone/>
+            </a:pPr>
+            <a:r>
+              <a:rPr lang="en-US" sz="950" b="1" kern="0" spc="130" dirty="0">
+                <a:solidFill>
+                  <a:srgbClr val="1E3A5F"/>
+                </a:solidFill>
+                <a:latin typeface="Calibri" pitchFamily="34" charset="0"/>
+                <a:ea typeface="Calibri" pitchFamily="34" charset="-122"/>
+                <a:cs typeface="Calibri" pitchFamily="34" charset="-120"/>
+              </a:rPr>
+              <a:t>THỰC HIỆN</a:t>
+            </a:r>
+            <a:endParaRPr lang="en-US" sz="950" dirty="0"/>
+          </a:p>
+        </p:txBody>
+      </p:sp>
+      <p:sp>
+        <p:nvSpPr>
+          <p:cNvPr id="20" name="Text 18"/>
+          <p:cNvSpPr txBox="1"/>
+          <p:nvPr/>
+        </p:nvSpPr>
+        <p:spPr>
+          <a:xfrm>
+            <a:off x="4624730" y="2774877"/>
+            <a:ext cx="2942234" cy="457200"/>
+          </a:xfrm>
+          <a:prstGeom prst="rect">
+            <a:avLst/>
+          </a:prstGeom>
+          <a:noFill/>
+          <a:ln/>
+        </p:spPr>
+        <p:txBody>
+          <a:bodyPr wrap="square" lIns="0" tIns="0" rIns="0" bIns="0" rtlCol="0" anchor="t"/>
+          <a:lstStyle/>
+          <a:p>
+            <a:pPr marL="0" indent="0">
+              <a:lnSpc>
+                <a:spcPts val="1700"/>
+              </a:lnSpc>
+              <a:buNone/>
+            </a:pPr>
+            <a:r>
+              <a:rPr lang="en-US" sz="1400" b="1" dirty="0">
+                <a:solidFill>
+                  <a:srgbClr val="1E3A5F"/>
+                </a:solidFill>
+                <a:latin typeface="Arial" pitchFamily="34" charset="0"/>
+                <a:ea typeface="Arial" pitchFamily="34" charset="-122"/>
+                <a:cs typeface="Arial" pitchFamily="34" charset="-120"/>
+              </a:rPr>
+              <a:t>Bộ dữ liệu và mô hình 1</a:t>
+            </a:r>
+            <a:endParaRPr lang="en-US" sz="1400" dirty="0"/>
+          </a:p>
+        </p:txBody>
+      </p:sp>
+      <p:sp>
+        <p:nvSpPr>
+          <p:cNvPr id="21" name="Text 19"/>
+          <p:cNvSpPr txBox="1"/>
+          <p:nvPr/>
+        </p:nvSpPr>
+        <p:spPr>
+          <a:xfrm>
+            <a:off x="4624730" y="3305229"/>
+            <a:ext cx="2997098" cy="2121408"/>
+          </a:xfrm>
+          <a:prstGeom prst="rect">
+            <a:avLst/>
+          </a:prstGeom>
+          <a:noFill/>
+          <a:ln/>
+        </p:spPr>
+        <p:txBody>
+          <a:bodyPr wrap="square" lIns="0" tIns="0" rIns="0" bIns="0" rtlCol="0" anchor="t"/>
+          <a:lstStyle/>
           <a:p>
             <a:pPr marL="177800" indent="-177800">
               <a:lnSpc>
@@ -8645,7 +9306,84 @@
                 <a:ea typeface="Calibri" pitchFamily="34" charset="-122"/>
                 <a:cs typeface="Calibri" pitchFamily="34" charset="-120"/>
               </a:rPr>
-              <a:t>Rò rỉ dữ liệu: chia tập theo khung hình so với chia theo người</a:t>
+              <a:t>Quay 6 hành </a:t>
+            </a:r>
+            <a:r>
+              <a:rPr lang="en-US" sz="1150" dirty="0" err="1">
+                <a:solidFill>
+                  <a:srgbClr val="3C4A5C"/>
+                </a:solidFill>
+                <a:latin typeface="Calibri" pitchFamily="34" charset="0"/>
+                <a:ea typeface="Calibri" pitchFamily="34" charset="-122"/>
+                <a:cs typeface="Calibri" pitchFamily="34" charset="-120"/>
+              </a:rPr>
+              <a:t>động</a:t>
+            </a:r>
+            <a:r>
+              <a:rPr lang="en-US" sz="1150" dirty="0">
+                <a:solidFill>
+                  <a:srgbClr val="3C4A5C"/>
+                </a:solidFill>
+                <a:latin typeface="Calibri" pitchFamily="34" charset="0"/>
+                <a:ea typeface="Calibri" pitchFamily="34" charset="-122"/>
+                <a:cs typeface="Calibri" pitchFamily="34" charset="-120"/>
+              </a:rPr>
+              <a:t> </a:t>
+            </a:r>
+            <a:r>
+              <a:rPr lang="en-US" sz="1150" dirty="0" err="1" smtClean="0">
+                <a:solidFill>
+                  <a:srgbClr val="3C4A5C"/>
+                </a:solidFill>
+                <a:latin typeface="Calibri" pitchFamily="34" charset="0"/>
+                <a:ea typeface="Calibri" pitchFamily="34" charset="-122"/>
+                <a:cs typeface="Calibri" pitchFamily="34" charset="-120"/>
+              </a:rPr>
+              <a:t>với</a:t>
+            </a:r>
+            <a:r>
+              <a:rPr lang="en-US" sz="1150" dirty="0">
+                <a:solidFill>
+                  <a:srgbClr val="3C4A5C"/>
+                </a:solidFill>
+                <a:latin typeface="Calibri" pitchFamily="34" charset="0"/>
+                <a:ea typeface="Calibri" pitchFamily="34" charset="-122"/>
+                <a:cs typeface="Calibri" pitchFamily="34" charset="-120"/>
+              </a:rPr>
+              <a:t> </a:t>
+            </a:r>
+            <a:r>
+              <a:rPr lang="en-US" sz="1150" dirty="0" err="1" smtClean="0">
+                <a:solidFill>
+                  <a:srgbClr val="3C4A5C"/>
+                </a:solidFill>
+                <a:latin typeface="Calibri" pitchFamily="34" charset="0"/>
+                <a:ea typeface="Calibri" pitchFamily="34" charset="-122"/>
+                <a:cs typeface="Calibri" pitchFamily="34" charset="-120"/>
+              </a:rPr>
+              <a:t>người</a:t>
+            </a:r>
+            <a:r>
+              <a:rPr lang="en-US" sz="1150" dirty="0" smtClean="0">
+                <a:solidFill>
+                  <a:srgbClr val="3C4A5C"/>
+                </a:solidFill>
+                <a:latin typeface="Calibri" pitchFamily="34" charset="0"/>
+                <a:ea typeface="Calibri" pitchFamily="34" charset="-122"/>
+                <a:cs typeface="Calibri" pitchFamily="34" charset="-120"/>
+              </a:rPr>
+              <a:t> </a:t>
+            </a:r>
+            <a:r>
+              <a:rPr lang="en-US" sz="1150" dirty="0">
+                <a:solidFill>
+                  <a:srgbClr val="3C4A5C"/>
+                </a:solidFill>
+                <a:latin typeface="Calibri" pitchFamily="34" charset="0"/>
+                <a:ea typeface="Calibri" pitchFamily="34" charset="-122"/>
+                <a:cs typeface="Calibri" pitchFamily="34" charset="-120"/>
+              </a:rPr>
+              <a:t>diễn, mỗi hành động 8–10 lần</a:t>
             </a:r>
             <a:endParaRPr lang="en-US" sz="1150" dirty="0"/>
           </a:p>
@@ -8669,140 +9407,10 @@
                 <a:ea typeface="Calibri" pitchFamily="34" charset="-122"/>
                 <a:cs typeface="Calibri" pitchFamily="34" charset="-120"/>
               </a:rPr>
-              <a:t>Rừng ngẫu nhiên: nhiều cây bỏ phiếu, xếp hạng được đặc trưng quan trọng</a:t>
+              <a:t>Trích khung xương một lần duy nhất, lưu ra tệp .npy</a:t>
             </a:r>
             <a:endParaRPr lang="en-US" sz="1150" dirty="0"/>
           </a:p>
-        </p:txBody>
-      </p:sp>
-      <p:sp>
-        <p:nvSpPr>
-          <p:cNvPr id="18" name="Shape 16"/>
-          <p:cNvSpPr/>
-          <p:nvPr/>
-        </p:nvSpPr>
-        <p:spPr>
-          <a:xfrm>
-            <a:off x="4368698" y="2281101"/>
-            <a:ext cx="3454298" cy="3291840"/>
-          </a:xfrm>
-          <a:prstGeom prst="roundRect">
-            <a:avLst>
-              <a:gd name="adj" fmla="val 1667"/>
-            </a:avLst>
-          </a:prstGeom>
-          <a:solidFill>
-            <a:srgbClr val="F4F7FA"/>
-          </a:solidFill>
-          <a:ln w="9525">
-            <a:solidFill>
-              <a:srgbClr val="DDE4ED"/>
-            </a:solidFill>
-            <a:prstDash val="solid"/>
-          </a:ln>
-        </p:spPr>
-      </p:sp>
-      <p:sp>
-        <p:nvSpPr>
-          <p:cNvPr id="19" name="Text 17"/>
-          <p:cNvSpPr txBox="1"/>
-          <p:nvPr/>
-        </p:nvSpPr>
-        <p:spPr>
-          <a:xfrm>
-            <a:off x="4624730" y="2518845"/>
-            <a:ext cx="2942234" cy="201168"/>
-          </a:xfrm>
-          <a:prstGeom prst="rect">
-            <a:avLst/>
-          </a:prstGeom>
-          <a:noFill/>
-          <a:ln/>
-        </p:spPr>
-        <p:txBody>
-          <a:bodyPr wrap="square" lIns="0" tIns="0" rIns="0" bIns="0" rtlCol="0" anchor="t"/>
-          <a:lstStyle/>
-          <a:p>
-            <a:pPr marL="0" indent="0">
-              <a:buNone/>
-            </a:pPr>
-            <a:r>
-              <a:rPr lang="en-US" sz="950" b="1" kern="0" spc="130" dirty="0">
-                <a:solidFill>
-                  <a:srgbClr val="1E3A5F"/>
-                </a:solidFill>
-                <a:latin typeface="Calibri" pitchFamily="34" charset="0"/>
-                <a:ea typeface="Calibri" pitchFamily="34" charset="-122"/>
-                <a:cs typeface="Calibri" pitchFamily="34" charset="-120"/>
-              </a:rPr>
-              <a:t>THỰC HIỆN</a:t>
-            </a:r>
-            <a:endParaRPr lang="en-US" sz="950" dirty="0"/>
-          </a:p>
-        </p:txBody>
-      </p:sp>
-      <p:sp>
-        <p:nvSpPr>
-          <p:cNvPr id="20" name="Text 18"/>
-          <p:cNvSpPr txBox="1"/>
-          <p:nvPr/>
-        </p:nvSpPr>
-        <p:spPr>
-          <a:xfrm>
-            <a:off x="4624730" y="2774877"/>
-            <a:ext cx="2942234" cy="457200"/>
-          </a:xfrm>
-          <a:prstGeom prst="rect">
-            <a:avLst/>
-          </a:prstGeom>
-          <a:noFill/>
-          <a:ln/>
-        </p:spPr>
-        <p:txBody>
-          <a:bodyPr wrap="square" lIns="0" tIns="0" rIns="0" bIns="0" rtlCol="0" anchor="t"/>
-          <a:lstStyle/>
-          <a:p>
-            <a:pPr marL="0" indent="0">
-              <a:lnSpc>
-                <a:spcPts val="1700"/>
-              </a:lnSpc>
-              <a:buNone/>
-            </a:pPr>
-            <a:r>
-              <a:rPr lang="en-US" sz="1400" b="1" dirty="0">
-                <a:solidFill>
-                  <a:srgbClr val="1E3A5F"/>
-                </a:solidFill>
-                <a:latin typeface="Arial" pitchFamily="34" charset="0"/>
-                <a:ea typeface="Arial" pitchFamily="34" charset="-122"/>
-                <a:cs typeface="Arial" pitchFamily="34" charset="-120"/>
-              </a:rPr>
-              <a:t>Bộ dữ liệu và mô hình 1</a:t>
-            </a:r>
-            <a:endParaRPr lang="en-US" sz="1400" dirty="0"/>
-          </a:p>
-        </p:txBody>
-      </p:sp>
-      <p:sp>
-        <p:nvSpPr>
-          <p:cNvPr id="21" name="Text 19"/>
-          <p:cNvSpPr txBox="1"/>
-          <p:nvPr/>
-        </p:nvSpPr>
-        <p:spPr>
-          <a:xfrm>
-            <a:off x="4624730" y="3305229"/>
-            <a:ext cx="2997098" cy="2121408"/>
-          </a:xfrm>
-          <a:prstGeom prst="rect">
-            <a:avLst/>
-          </a:prstGeom>
-          <a:noFill/>
-          <a:ln/>
-        </p:spPr>
-        <p:txBody>
-          <a:bodyPr wrap="square" lIns="0" tIns="0" rIns="0" bIns="0" rtlCol="0" anchor="t"/>
-          <a:lstStyle/>
           <a:p>
             <a:pPr marL="177800" indent="-177800">
               <a:lnSpc>
@@ -8823,10 +9431,173 @@
                 <a:ea typeface="Calibri" pitchFamily="34" charset="-122"/>
                 <a:cs typeface="Calibri" pitchFamily="34" charset="-120"/>
               </a:rPr>
-              <a:t>Quay 6 hành động với 3–5 người diễn, mỗi hành động 8–10 lần</a:t>
+              <a:t>Cắt cửa sổ 30 khung, tính 30–40 đặc trưng cho mỗi </a:t>
+            </a:r>
+            <a:r>
+              <a:rPr lang="en-US" sz="1150" dirty="0" err="1">
+                <a:solidFill>
+                  <a:srgbClr val="3C4A5C"/>
+                </a:solidFill>
+                <a:latin typeface="Calibri" pitchFamily="34" charset="0"/>
+                <a:ea typeface="Calibri" pitchFamily="34" charset="-122"/>
+                <a:cs typeface="Calibri" pitchFamily="34" charset="-120"/>
+              </a:rPr>
+              <a:t>cửa</a:t>
+            </a:r>
+            <a:r>
+              <a:rPr lang="en-US" sz="1150" dirty="0">
+                <a:solidFill>
+                  <a:srgbClr val="3C4A5C"/>
+                </a:solidFill>
+                <a:latin typeface="Calibri" pitchFamily="34" charset="0"/>
+                <a:ea typeface="Calibri" pitchFamily="34" charset="-122"/>
+                <a:cs typeface="Calibri" pitchFamily="34" charset="-120"/>
+              </a:rPr>
+              <a:t> </a:t>
+            </a:r>
+            <a:r>
+              <a:rPr lang="en-US" sz="1150" dirty="0" err="1" smtClean="0">
+                <a:solidFill>
+                  <a:srgbClr val="3C4A5C"/>
+                </a:solidFill>
+                <a:latin typeface="Calibri" pitchFamily="34" charset="0"/>
+                <a:ea typeface="Calibri" pitchFamily="34" charset="-122"/>
+                <a:cs typeface="Calibri" pitchFamily="34" charset="-120"/>
+              </a:rPr>
+              <a:t>sổ</a:t>
             </a:r>
             <a:endParaRPr lang="en-US" sz="1150" dirty="0"/>
           </a:p>
+        </p:txBody>
+      </p:sp>
+      <p:sp>
+        <p:nvSpPr>
+          <p:cNvPr id="22" name="Shape 20"/>
+          <p:cNvSpPr/>
+          <p:nvPr/>
+        </p:nvSpPr>
+        <p:spPr>
+          <a:xfrm>
+            <a:off x="8097317" y="2281101"/>
+            <a:ext cx="3454298" cy="3291840"/>
+          </a:xfrm>
+          <a:prstGeom prst="roundRect">
+            <a:avLst>
+              <a:gd name="adj" fmla="val 1667"/>
+            </a:avLst>
+          </a:prstGeom>
+          <a:solidFill>
+            <a:srgbClr val="FFFFFF"/>
+          </a:solidFill>
+          <a:ln w="9525">
+            <a:solidFill>
+              <a:srgbClr val="00A88F"/>
+            </a:solidFill>
+            <a:prstDash val="solid"/>
+          </a:ln>
+        </p:spPr>
+      </p:sp>
+      <p:sp>
+        <p:nvSpPr>
+          <p:cNvPr id="23" name="Text 21"/>
+          <p:cNvSpPr txBox="1"/>
+          <p:nvPr/>
+        </p:nvSpPr>
+        <p:spPr>
+          <a:xfrm>
+            <a:off x="8353349" y="2518845"/>
+            <a:ext cx="2942234" cy="201168"/>
+          </a:xfrm>
+          <a:prstGeom prst="rect">
+            <a:avLst/>
+          </a:prstGeom>
+          <a:noFill/>
+          <a:ln/>
+        </p:spPr>
+        <p:txBody>
+          <a:bodyPr wrap="square" lIns="0" tIns="0" rIns="0" bIns="0" rtlCol="0" anchor="t"/>
+          <a:lstStyle/>
+          <a:p>
+            <a:pPr marL="0" indent="0">
+              <a:buNone/>
+            </a:pPr>
+            <a:r>
+              <a:rPr lang="en-US" sz="950" b="1" kern="0" spc="130" dirty="0" smtClean="0">
+                <a:solidFill>
+                  <a:srgbClr val="00806D"/>
+                </a:solidFill>
+                <a:latin typeface="Calibri" pitchFamily="34" charset="0"/>
+                <a:ea typeface="Calibri" pitchFamily="34" charset="-122"/>
+                <a:cs typeface="Calibri" pitchFamily="34" charset="-120"/>
+              </a:rPr>
+              <a:t>MỤC TIÊU</a:t>
+            </a:r>
+            <a:endParaRPr lang="en-US" sz="950" dirty="0"/>
+          </a:p>
+        </p:txBody>
+      </p:sp>
+      <p:sp>
+        <p:nvSpPr>
+          <p:cNvPr id="24" name="Text 22"/>
+          <p:cNvSpPr txBox="1"/>
+          <p:nvPr/>
+        </p:nvSpPr>
+        <p:spPr>
+          <a:xfrm>
+            <a:off x="8353349" y="2774877"/>
+            <a:ext cx="2942234" cy="457200"/>
+          </a:xfrm>
+          <a:prstGeom prst="rect">
+            <a:avLst/>
+          </a:prstGeom>
+          <a:noFill/>
+          <a:ln/>
+        </p:spPr>
+        <p:txBody>
+          <a:bodyPr wrap="square" lIns="0" tIns="0" rIns="0" bIns="0" rtlCol="0" anchor="t"/>
+          <a:lstStyle/>
+          <a:p>
+            <a:pPr marL="0" indent="0">
+              <a:lnSpc>
+                <a:spcPts val="1700"/>
+              </a:lnSpc>
+              <a:buNone/>
+            </a:pPr>
+            <a:r>
+              <a:rPr lang="en-US" sz="1400" b="1" dirty="0">
+                <a:solidFill>
+                  <a:srgbClr val="1E3A5F"/>
+                </a:solidFill>
+                <a:latin typeface="Arial" pitchFamily="34" charset="0"/>
+                <a:ea typeface="Arial" pitchFamily="34" charset="-122"/>
+                <a:cs typeface="Arial" pitchFamily="34" charset="-120"/>
+              </a:rPr>
+              <a:t>Sản phẩm ngày 22/10</a:t>
+            </a:r>
+            <a:endParaRPr lang="en-US" sz="1400" dirty="0"/>
+          </a:p>
+        </p:txBody>
+      </p:sp>
+      <p:sp>
+        <p:nvSpPr>
+          <p:cNvPr id="25" name="Text 23"/>
+          <p:cNvSpPr txBox="1"/>
+          <p:nvPr/>
+        </p:nvSpPr>
+        <p:spPr>
+          <a:xfrm>
+            <a:off x="8353349" y="3305229"/>
+            <a:ext cx="2997098" cy="2121408"/>
+          </a:xfrm>
+          <a:prstGeom prst="rect">
+            <a:avLst/>
+          </a:prstGeom>
+          <a:noFill/>
+          <a:ln/>
+        </p:spPr>
+        <p:txBody>
+          <a:bodyPr wrap="square" lIns="0" tIns="0" rIns="0" bIns="0" rtlCol="0" anchor="t"/>
+          <a:lstStyle/>
           <a:p>
             <a:pPr marL="177800" indent="-177800">
               <a:lnSpc>
@@ -8847,7 +9618,7 @@
                 <a:ea typeface="Calibri" pitchFamily="34" charset="-122"/>
                 <a:cs typeface="Calibri" pitchFamily="34" charset="-120"/>
               </a:rPr>
-              <a:t>Trích khung xương một lần duy nhất, lưu ra tệp .npy</a:t>
+              <a:t>Bộ dữ liệu kèm bảng thống kê theo người và theo hành động</a:t>
             </a:r>
             <a:endParaRPr lang="en-US" sz="1150" dirty="0"/>
           </a:p>
@@ -8863,6 +9634,28 @@
               <a:buChar char="•"/>
             </a:pPr>
             <a:r>
+              <a:rPr lang="en-US" sz="1150" dirty="0" err="1" smtClean="0">
+                <a:solidFill>
+                  <a:srgbClr val="3C4A5C"/>
+                </a:solidFill>
+                <a:latin typeface="Calibri" pitchFamily="34" charset="0"/>
+                <a:ea typeface="Calibri" pitchFamily="34" charset="-122"/>
+                <a:cs typeface="Calibri" pitchFamily="34" charset="-120"/>
+              </a:rPr>
+              <a:t>Hệ</a:t>
+            </a:r>
+            <a:r>
+              <a:rPr lang="en-US" sz="1150" dirty="0" smtClean="0">
+                <a:solidFill>
+                  <a:srgbClr val="3C4A5C"/>
+                </a:solidFill>
+                <a:latin typeface="Calibri" pitchFamily="34" charset="0"/>
+                <a:ea typeface="Calibri" pitchFamily="34" charset="-122"/>
+                <a:cs typeface="Calibri" pitchFamily="34" charset="-120"/>
+              </a:rPr>
+              <a:t> </a:t>
+            </a:r>
+            <a:r>
               <a:rPr lang="en-US" sz="1150" dirty="0">
                 <a:solidFill>
                   <a:srgbClr val="3C4A5C"/>
@@ -8871,257 +9664,7 @@
                 <a:ea typeface="Calibri" pitchFamily="34" charset="-122"/>
                 <a:cs typeface="Calibri" pitchFamily="34" charset="-120"/>
               </a:rPr>
-              <a:t>Cắt cửa sổ 30 khung, tính 30–40 đặc trưng cho mỗi cửa sổ</a:t>
-            </a:r>
-            <a:endParaRPr lang="en-US" sz="1150" dirty="0"/>
-          </a:p>
-          <a:p>
-            <a:pPr marL="177800" indent="-177800">
-              <a:lnSpc>
-                <a:spcPts val="1500"/>
-              </a:lnSpc>
-              <a:spcAft>
-                <a:spcPts val="600"/>
-              </a:spcAft>
-              <a:buSzPct val="100000"/>
-              <a:buChar char="•"/>
-            </a:pPr>
-            <a:r>
-              <a:rPr lang="en-US" sz="1150" dirty="0">
-                <a:solidFill>
-                  <a:srgbClr val="3C4A5C"/>
-                </a:solidFill>
-                <a:latin typeface="Calibri" pitchFamily="34" charset="0"/>
-                <a:ea typeface="Calibri" pitchFamily="34" charset="-122"/>
-                <a:cs typeface="Calibri" pitchFamily="34" charset="-120"/>
-              </a:rPr>
-              <a:t>Huấn luyện rừng ngẫu nhiên, chia tập theo người diễn</a:t>
-            </a:r>
-            <a:endParaRPr lang="en-US" sz="1150" dirty="0"/>
-          </a:p>
-          <a:p>
-            <a:pPr marL="177800" indent="-177800">
-              <a:lnSpc>
-                <a:spcPts val="1500"/>
-              </a:lnSpc>
-              <a:spcAft>
-                <a:spcPts val="600"/>
-              </a:spcAft>
-              <a:buSzPct val="100000"/>
-              <a:buChar char="•"/>
-            </a:pPr>
-            <a:r>
-              <a:rPr lang="en-US" sz="1150" dirty="0">
-                <a:solidFill>
-                  <a:srgbClr val="3C4A5C"/>
-                </a:solidFill>
-                <a:latin typeface="Calibri" pitchFamily="34" charset="0"/>
-                <a:ea typeface="Calibri" pitchFamily="34" charset="-122"/>
-                <a:cs typeface="Calibri" pitchFamily="34" charset="-120"/>
-              </a:rPr>
-              <a:t>Vẽ ma trận nhầm lẫn và xem đặc trưng nào có trọng số cao nhất</a:t>
-            </a:r>
-            <a:endParaRPr lang="en-US" sz="1150" dirty="0"/>
-          </a:p>
-        </p:txBody>
-      </p:sp>
-      <p:sp>
-        <p:nvSpPr>
-          <p:cNvPr id="22" name="Shape 20"/>
-          <p:cNvSpPr/>
-          <p:nvPr/>
-        </p:nvSpPr>
-        <p:spPr>
-          <a:xfrm>
-            <a:off x="8097317" y="2281101"/>
-            <a:ext cx="3454298" cy="3291840"/>
-          </a:xfrm>
-          <a:prstGeom prst="roundRect">
-            <a:avLst>
-              <a:gd name="adj" fmla="val 1667"/>
-            </a:avLst>
-          </a:prstGeom>
-          <a:solidFill>
-            <a:srgbClr val="FFFFFF"/>
-          </a:solidFill>
-          <a:ln w="9525">
-            <a:solidFill>
-              <a:srgbClr val="00A88F"/>
-            </a:solidFill>
-            <a:prstDash val="solid"/>
-          </a:ln>
-        </p:spPr>
-      </p:sp>
-      <p:sp>
-        <p:nvSpPr>
-          <p:cNvPr id="23" name="Text 21"/>
-          <p:cNvSpPr txBox="1"/>
-          <p:nvPr/>
-        </p:nvSpPr>
-        <p:spPr>
-          <a:xfrm>
-            <a:off x="8353349" y="2518845"/>
-            <a:ext cx="2942234" cy="201168"/>
-          </a:xfrm>
-          <a:prstGeom prst="rect">
-            <a:avLst/>
-          </a:prstGeom>
-          <a:noFill/>
-          <a:ln/>
-        </p:spPr>
-        <p:txBody>
-          <a:bodyPr wrap="square" lIns="0" tIns="0" rIns="0" bIns="0" rtlCol="0" anchor="t"/>
-          <a:lstStyle/>
-          <a:p>
-            <a:pPr marL="0" indent="0">
-              <a:buNone/>
-            </a:pPr>
-            <a:r>
-              <a:rPr lang="en-US" sz="950" b="1" kern="0" spc="130" dirty="0" smtClean="0">
-                <a:solidFill>
-                  <a:srgbClr val="00806D"/>
-                </a:solidFill>
-                <a:latin typeface="Calibri" pitchFamily="34" charset="0"/>
-                <a:ea typeface="Calibri" pitchFamily="34" charset="-122"/>
-                <a:cs typeface="Calibri" pitchFamily="34" charset="-120"/>
-              </a:rPr>
-              <a:t>MỤC TIÊU</a:t>
-            </a:r>
-            <a:endParaRPr lang="en-US" sz="950" dirty="0"/>
-          </a:p>
-        </p:txBody>
-      </p:sp>
-      <p:sp>
-        <p:nvSpPr>
-          <p:cNvPr id="24" name="Text 22"/>
-          <p:cNvSpPr txBox="1"/>
-          <p:nvPr/>
-        </p:nvSpPr>
-        <p:spPr>
-          <a:xfrm>
-            <a:off x="8353349" y="2774877"/>
-            <a:ext cx="2942234" cy="457200"/>
-          </a:xfrm>
-          <a:prstGeom prst="rect">
-            <a:avLst/>
-          </a:prstGeom>
-          <a:noFill/>
-          <a:ln/>
-        </p:spPr>
-        <p:txBody>
-          <a:bodyPr wrap="square" lIns="0" tIns="0" rIns="0" bIns="0" rtlCol="0" anchor="t"/>
-          <a:lstStyle/>
-          <a:p>
-            <a:pPr marL="0" indent="0">
-              <a:lnSpc>
-                <a:spcPts val="1700"/>
-              </a:lnSpc>
-              <a:buNone/>
-            </a:pPr>
-            <a:r>
-              <a:rPr lang="en-US" sz="1400" b="1" dirty="0">
-                <a:solidFill>
-                  <a:srgbClr val="1E3A5F"/>
-                </a:solidFill>
-                <a:latin typeface="Arial" pitchFamily="34" charset="0"/>
-                <a:ea typeface="Arial" pitchFamily="34" charset="-122"/>
-                <a:cs typeface="Arial" pitchFamily="34" charset="-120"/>
-              </a:rPr>
-              <a:t>Sản phẩm ngày 22/10</a:t>
-            </a:r>
-            <a:endParaRPr lang="en-US" sz="1400" dirty="0"/>
-          </a:p>
-        </p:txBody>
-      </p:sp>
-      <p:sp>
-        <p:nvSpPr>
-          <p:cNvPr id="25" name="Text 23"/>
-          <p:cNvSpPr txBox="1"/>
-          <p:nvPr/>
-        </p:nvSpPr>
-        <p:spPr>
-          <a:xfrm>
-            <a:off x="8353349" y="3305229"/>
-            <a:ext cx="2997098" cy="2121408"/>
-          </a:xfrm>
-          <a:prstGeom prst="rect">
-            <a:avLst/>
-          </a:prstGeom>
-          <a:noFill/>
-          <a:ln/>
-        </p:spPr>
-        <p:txBody>
-          <a:bodyPr wrap="square" lIns="0" tIns="0" rIns="0" bIns="0" rtlCol="0" anchor="t"/>
-          <a:lstStyle/>
-          <a:p>
-            <a:pPr marL="177800" indent="-177800">
-              <a:lnSpc>
-                <a:spcPts val="1500"/>
-              </a:lnSpc>
-              <a:spcAft>
-                <a:spcPts val="600"/>
-              </a:spcAft>
-              <a:buSzPct val="100000"/>
-              <a:buChar char="•"/>
-            </a:pPr>
-            <a:r>
-              <a:rPr lang="en-US" sz="1150" dirty="0">
-                <a:solidFill>
-                  <a:srgbClr val="3C4A5C"/>
-                </a:solidFill>
-                <a:latin typeface="Calibri" pitchFamily="34" charset="0"/>
-                <a:ea typeface="Calibri" pitchFamily="34" charset="-122"/>
-                <a:cs typeface="Calibri" pitchFamily="34" charset="-120"/>
-              </a:rPr>
-              <a:t>Bộ dữ liệu kèm bảng thống kê theo người và theo hành động</a:t>
-            </a:r>
-            <a:endParaRPr lang="en-US" sz="1150" dirty="0"/>
-          </a:p>
-          <a:p>
-            <a:pPr marL="177800" indent="-177800">
-              <a:lnSpc>
-                <a:spcPts val="1500"/>
-              </a:lnSpc>
-              <a:spcAft>
-                <a:spcPts val="600"/>
-              </a:spcAft>
-              <a:buSzPct val="100000"/>
-              <a:buChar char="•"/>
-            </a:pPr>
-            <a:r>
-              <a:rPr lang="en-US" sz="1150" dirty="0">
-                <a:solidFill>
-                  <a:srgbClr val="3C4A5C"/>
-                </a:solidFill>
-                <a:latin typeface="Calibri" pitchFamily="34" charset="0"/>
-                <a:ea typeface="Calibri" pitchFamily="34" charset="-122"/>
-                <a:cs typeface="Calibri" pitchFamily="34" charset="-120"/>
-              </a:rPr>
-              <a:t>Ma trận nhầm lẫn, bảng precision và recall từng lớp</a:t>
-            </a:r>
-            <a:endParaRPr lang="en-US" sz="1150" dirty="0"/>
-          </a:p>
-          <a:p>
-            <a:pPr marL="177800" indent="-177800">
-              <a:lnSpc>
-                <a:spcPts val="1500"/>
-              </a:lnSpc>
-              <a:spcAft>
-                <a:spcPts val="600"/>
-              </a:spcAft>
-              <a:buSzPct val="100000"/>
-              <a:buChar char="•"/>
-            </a:pPr>
-            <a:r>
-              <a:rPr lang="en-US" sz="1150" dirty="0">
-                <a:solidFill>
-                  <a:srgbClr val="3C4A5C"/>
-                </a:solidFill>
-                <a:latin typeface="Calibri" pitchFamily="34" charset="0"/>
-                <a:ea typeface="Calibri" pitchFamily="34" charset="-122"/>
-                <a:cs typeface="Calibri" pitchFamily="34" charset="-120"/>
-              </a:rPr>
-              <a:t>Hệ thống phân loại chạy được từ đầu đến cuối</a:t>
+              <a:t>thống phân loại chạy được từ đầu đến cuối</a:t>
             </a:r>
             <a:endParaRPr lang="en-US" sz="1150" dirty="0"/>
           </a:p>
@@ -9692,7 +10235,7 @@
                 <a:ea typeface="Arial" pitchFamily="34" charset="-122"/>
                 <a:cs typeface="Arial" pitchFamily="34" charset="-120"/>
               </a:rPr>
-              <a:t>RNN</a:t>
+              <a:t>RNN </a:t>
             </a:r>
             <a:r>
               <a:rPr lang="en-US" sz="1400" b="1" dirty="0">
@@ -9703,7 +10246,7 @@
                 <a:ea typeface="Arial" pitchFamily="34" charset="-122"/>
                 <a:cs typeface="Arial" pitchFamily="34" charset="-120"/>
               </a:rPr>
-              <a:t>, LSTM và PyTorch</a:t>
+              <a:t>và PyTorch</a:t>
             </a:r>
             <a:endParaRPr lang="en-US" sz="1400" dirty="0"/>
           </a:p>
@@ -9741,6 +10284,17 @@
               <a:buChar char="•"/>
             </a:pPr>
             <a:r>
+              <a:rPr lang="en-US" sz="1150" dirty="0" smtClean="0">
+                <a:solidFill>
+                  <a:srgbClr val="3C4A5C"/>
+                </a:solidFill>
+                <a:latin typeface="Calibri" pitchFamily="34" charset="0"/>
+                <a:ea typeface="Calibri" pitchFamily="34" charset="-122"/>
+                <a:cs typeface="Calibri" pitchFamily="34" charset="-120"/>
+              </a:rPr>
+              <a:t>RNN </a:t>
+            </a:r>
+            <a:r>
               <a:rPr lang="en-US" sz="1150" dirty="0">
                 <a:solidFill>
                   <a:srgbClr val="3C4A5C"/>
@@ -9749,7 +10303,7 @@
                 <a:ea typeface="Calibri" pitchFamily="34" charset="-122"/>
                 <a:cs typeface="Calibri" pitchFamily="34" charset="-120"/>
               </a:rPr>
-              <a:t>Vì sao mạng thông thường khó xử lý chuỗi có độ dài thay đổi</a:t>
+              <a:t>và trạng thái ẩn, vấn đề tiêu biến gradient</a:t>
             </a:r>
             <a:endParaRPr lang="en-US" sz="1150" dirty="0"/>
           </a:p>
@@ -9765,6 +10319,28 @@
               <a:buChar char="•"/>
             </a:pPr>
             <a:r>
+              <a:rPr lang="en-US" sz="1150" dirty="0" err="1" smtClean="0">
+                <a:solidFill>
+                  <a:srgbClr val="3C4A5C"/>
+                </a:solidFill>
+                <a:latin typeface="Calibri" pitchFamily="34" charset="0"/>
+                <a:ea typeface="Calibri" pitchFamily="34" charset="-122"/>
+                <a:cs typeface="Calibri" pitchFamily="34" charset="-120"/>
+              </a:rPr>
+              <a:t>Quá</a:t>
+            </a:r>
+            <a:r>
+              <a:rPr lang="en-US" sz="1150" dirty="0" smtClean="0">
+                <a:solidFill>
+                  <a:srgbClr val="3C4A5C"/>
+                </a:solidFill>
+                <a:latin typeface="Calibri" pitchFamily="34" charset="0"/>
+                <a:ea typeface="Calibri" pitchFamily="34" charset="-122"/>
+                <a:cs typeface="Calibri" pitchFamily="34" charset="-120"/>
+              </a:rPr>
+              <a:t> </a:t>
+            </a:r>
+            <a:r>
               <a:rPr lang="en-US" sz="1150" dirty="0">
                 <a:solidFill>
                   <a:srgbClr val="3C4A5C"/>
@@ -9773,7 +10349,7 @@
                 <a:ea typeface="Calibri" pitchFamily="34" charset="-122"/>
                 <a:cs typeface="Calibri" pitchFamily="34" charset="-120"/>
               </a:rPr>
-              <a:t>RNN và trạng thái ẩn, vấn đề tiêu biến gradient</a:t>
+              <a:t>khớp và cách hạn chế: dropout, giảm kích thước ẩn, tăng cường dữ liệu</a:t>
             </a:r>
             <a:endParaRPr lang="en-US" sz="1150" dirty="0"/>
           </a:p>
@@ -9797,10 +10373,162 @@
                 <a:ea typeface="Calibri" pitchFamily="34" charset="-122"/>
                 <a:cs typeface="Calibri" pitchFamily="34" charset="-120"/>
               </a:rPr>
-              <a:t>LSTM: trực giác về cổng quên, cổng vào, cổng ra</a:t>
+              <a:t>PyTorch: </a:t>
+            </a:r>
+            <a:r>
+              <a:rPr lang="en-US" sz="1150" dirty="0" smtClean="0">
+                <a:solidFill>
+                  <a:srgbClr val="3C4A5C"/>
+                </a:solidFill>
+                <a:latin typeface="Calibri" pitchFamily="34" charset="0"/>
+                <a:ea typeface="Calibri" pitchFamily="34" charset="-122"/>
+                <a:cs typeface="Calibri" pitchFamily="34" charset="-120"/>
+              </a:rPr>
+              <a:t>tensor, </a:t>
+            </a:r>
+            <a:r>
+              <a:rPr lang="en-US" sz="1150" dirty="0">
+                <a:solidFill>
+                  <a:srgbClr val="3C4A5C"/>
+                </a:solidFill>
+                <a:latin typeface="Calibri" pitchFamily="34" charset="0"/>
+                <a:ea typeface="Calibri" pitchFamily="34" charset="-122"/>
+                <a:cs typeface="Calibri" pitchFamily="34" charset="-120"/>
+              </a:rPr>
+              <a:t>cấu trúc một vòng lặp huấn luyện</a:t>
             </a:r>
             <a:endParaRPr lang="en-US" sz="1150" dirty="0"/>
           </a:p>
+        </p:txBody>
+      </p:sp>
+      <p:sp>
+        <p:nvSpPr>
+          <p:cNvPr id="18" name="Shape 16"/>
+          <p:cNvSpPr/>
+          <p:nvPr/>
+        </p:nvSpPr>
+        <p:spPr>
+          <a:xfrm>
+            <a:off x="4368698" y="2377440"/>
+            <a:ext cx="3454298" cy="3291840"/>
+          </a:xfrm>
+          <a:prstGeom prst="roundRect">
+            <a:avLst>
+              <a:gd name="adj" fmla="val 1667"/>
+            </a:avLst>
+          </a:prstGeom>
+          <a:solidFill>
+            <a:srgbClr val="F4F7FA"/>
+          </a:solidFill>
+          <a:ln w="9525">
+            <a:solidFill>
+              <a:srgbClr val="DDE4ED"/>
+            </a:solidFill>
+            <a:prstDash val="solid"/>
+          </a:ln>
+        </p:spPr>
+      </p:sp>
+      <p:sp>
+        <p:nvSpPr>
+          <p:cNvPr id="19" name="Text 17"/>
+          <p:cNvSpPr txBox="1"/>
+          <p:nvPr/>
+        </p:nvSpPr>
+        <p:spPr>
+          <a:xfrm>
+            <a:off x="4624730" y="2615184"/>
+            <a:ext cx="2942234" cy="201168"/>
+          </a:xfrm>
+          <a:prstGeom prst="rect">
+            <a:avLst/>
+          </a:prstGeom>
+          <a:noFill/>
+          <a:ln/>
+        </p:spPr>
+        <p:txBody>
+          <a:bodyPr wrap="square" lIns="0" tIns="0" rIns="0" bIns="0" rtlCol="0" anchor="t"/>
+          <a:lstStyle/>
+          <a:p>
+            <a:pPr marL="0" indent="0">
+              <a:buNone/>
+            </a:pPr>
+            <a:r>
+              <a:rPr lang="en-US" sz="950" b="1" kern="0" spc="130" dirty="0">
+                <a:solidFill>
+                  <a:srgbClr val="1E3A5F"/>
+                </a:solidFill>
+                <a:latin typeface="Calibri" pitchFamily="34" charset="0"/>
+                <a:ea typeface="Calibri" pitchFamily="34" charset="-122"/>
+                <a:cs typeface="Calibri" pitchFamily="34" charset="-120"/>
+              </a:rPr>
+              <a:t>THỰC HIỆN</a:t>
+            </a:r>
+            <a:endParaRPr lang="en-US" sz="950" dirty="0"/>
+          </a:p>
+        </p:txBody>
+      </p:sp>
+      <p:sp>
+        <p:nvSpPr>
+          <p:cNvPr id="20" name="Text 18"/>
+          <p:cNvSpPr txBox="1"/>
+          <p:nvPr/>
+        </p:nvSpPr>
+        <p:spPr>
+          <a:xfrm>
+            <a:off x="4624730" y="2871216"/>
+            <a:ext cx="2942234" cy="457200"/>
+          </a:xfrm>
+          <a:prstGeom prst="rect">
+            <a:avLst/>
+          </a:prstGeom>
+          <a:noFill/>
+          <a:ln/>
+        </p:spPr>
+        <p:txBody>
+          <a:bodyPr wrap="square" lIns="0" tIns="0" rIns="0" bIns="0" rtlCol="0" anchor="t"/>
+          <a:lstStyle/>
+          <a:p>
+            <a:pPr marL="0" indent="0">
+              <a:lnSpc>
+                <a:spcPts val="1700"/>
+              </a:lnSpc>
+              <a:buNone/>
+            </a:pPr>
+            <a:r>
+              <a:rPr lang="en-US" sz="1400" b="1" dirty="0">
+                <a:solidFill>
+                  <a:srgbClr val="1E3A5F"/>
+                </a:solidFill>
+                <a:latin typeface="Arial" pitchFamily="34" charset="0"/>
+                <a:ea typeface="Arial" pitchFamily="34" charset="-122"/>
+                <a:cs typeface="Arial" pitchFamily="34" charset="-120"/>
+              </a:rPr>
+              <a:t>Mô hình 2 và demo thời gian thực</a:t>
+            </a:r>
+            <a:endParaRPr lang="en-US" sz="1400" dirty="0"/>
+          </a:p>
+        </p:txBody>
+      </p:sp>
+      <p:sp>
+        <p:nvSpPr>
+          <p:cNvPr id="21" name="Text 19"/>
+          <p:cNvSpPr txBox="1"/>
+          <p:nvPr/>
+        </p:nvSpPr>
+        <p:spPr>
+          <a:xfrm>
+            <a:off x="4624730" y="3401568"/>
+            <a:ext cx="2997098" cy="2121408"/>
+          </a:xfrm>
+          <a:prstGeom prst="rect">
+            <a:avLst/>
+          </a:prstGeom>
+          <a:noFill/>
+          <a:ln/>
+        </p:spPr>
+        <p:txBody>
+          <a:bodyPr wrap="square" lIns="0" tIns="0" rIns="0" bIns="0" rtlCol="0" anchor="t"/>
+          <a:lstStyle/>
           <a:p>
             <a:pPr marL="177800" indent="-177800">
               <a:lnSpc>
@@ -9821,7 +10549,7 @@
                 <a:ea typeface="Calibri" pitchFamily="34" charset="-122"/>
                 <a:cs typeface="Calibri" pitchFamily="34" charset="-120"/>
               </a:rPr>
-              <a:t>Quá khớp và cách hạn chế: dropout, giảm kích thước ẩn, tăng cường dữ liệu</a:t>
+              <a:t>Cài PyTorch bản CPU, viết vòng lặp huấn luyện tối thiểu</a:t>
             </a:r>
             <a:endParaRPr lang="en-US" sz="1150" dirty="0"/>
           </a:p>
@@ -9837,6 +10565,28 @@
               <a:buChar char="•"/>
             </a:pPr>
             <a:r>
+              <a:rPr lang="en-US" sz="1150" dirty="0" err="1" smtClean="0">
+                <a:solidFill>
+                  <a:srgbClr val="3C4A5C"/>
+                </a:solidFill>
+                <a:latin typeface="Calibri" pitchFamily="34" charset="0"/>
+                <a:ea typeface="Calibri" pitchFamily="34" charset="-122"/>
+                <a:cs typeface="Calibri" pitchFamily="34" charset="-120"/>
+              </a:rPr>
+              <a:t>Khảo</a:t>
+            </a:r>
+            <a:r>
+              <a:rPr lang="en-US" sz="1150" dirty="0" smtClean="0">
+                <a:solidFill>
+                  <a:srgbClr val="3C4A5C"/>
+                </a:solidFill>
+                <a:latin typeface="Calibri" pitchFamily="34" charset="0"/>
+                <a:ea typeface="Calibri" pitchFamily="34" charset="-122"/>
+                <a:cs typeface="Calibri" pitchFamily="34" charset="-120"/>
+              </a:rPr>
+              <a:t> </a:t>
+            </a:r>
+            <a:r>
               <a:rPr lang="en-US" sz="1150" dirty="0">
                 <a:solidFill>
                   <a:srgbClr val="3C4A5C"/>
@@ -9845,140 +10595,10 @@
                 <a:ea typeface="Calibri" pitchFamily="34" charset="-122"/>
                 <a:cs typeface="Calibri" pitchFamily="34" charset="-120"/>
               </a:rPr>
-              <a:t>PyTorch: tensor, autograd, cấu trúc một vòng lặp huấn luyện</a:t>
+              <a:t>sát độ dài cửa sổ 15 / 30 / 45 khung hình</a:t>
             </a:r>
             <a:endParaRPr lang="en-US" sz="1150" dirty="0"/>
           </a:p>
-        </p:txBody>
-      </p:sp>
-      <p:sp>
-        <p:nvSpPr>
-          <p:cNvPr id="18" name="Shape 16"/>
-          <p:cNvSpPr/>
-          <p:nvPr/>
-        </p:nvSpPr>
-        <p:spPr>
-          <a:xfrm>
-            <a:off x="4368698" y="2377440"/>
-            <a:ext cx="3454298" cy="3291840"/>
-          </a:xfrm>
-          <a:prstGeom prst="roundRect">
-            <a:avLst>
-              <a:gd name="adj" fmla="val 1667"/>
-            </a:avLst>
-          </a:prstGeom>
-          <a:solidFill>
-            <a:srgbClr val="F4F7FA"/>
-          </a:solidFill>
-          <a:ln w="9525">
-            <a:solidFill>
-              <a:srgbClr val="DDE4ED"/>
-            </a:solidFill>
-            <a:prstDash val="solid"/>
-          </a:ln>
-        </p:spPr>
-      </p:sp>
-      <p:sp>
-        <p:nvSpPr>
-          <p:cNvPr id="19" name="Text 17"/>
-          <p:cNvSpPr txBox="1"/>
-          <p:nvPr/>
-        </p:nvSpPr>
-        <p:spPr>
-          <a:xfrm>
-            <a:off x="4624730" y="2615184"/>
-            <a:ext cx="2942234" cy="201168"/>
-          </a:xfrm>
-          <a:prstGeom prst="rect">
-            <a:avLst/>
-          </a:prstGeom>
-          <a:noFill/>
-          <a:ln/>
-        </p:spPr>
-        <p:txBody>
-          <a:bodyPr wrap="square" lIns="0" tIns="0" rIns="0" bIns="0" rtlCol="0" anchor="t"/>
-          <a:lstStyle/>
-          <a:p>
-            <a:pPr marL="0" indent="0">
-              <a:buNone/>
-            </a:pPr>
-            <a:r>
-              <a:rPr lang="en-US" sz="950" b="1" kern="0" spc="130" dirty="0">
-                <a:solidFill>
-                  <a:srgbClr val="1E3A5F"/>
-                </a:solidFill>
-                <a:latin typeface="Calibri" pitchFamily="34" charset="0"/>
-                <a:ea typeface="Calibri" pitchFamily="34" charset="-122"/>
-                <a:cs typeface="Calibri" pitchFamily="34" charset="-120"/>
-              </a:rPr>
-              <a:t>THỰC HIỆN</a:t>
-            </a:r>
-            <a:endParaRPr lang="en-US" sz="950" dirty="0"/>
-          </a:p>
-        </p:txBody>
-      </p:sp>
-      <p:sp>
-        <p:nvSpPr>
-          <p:cNvPr id="20" name="Text 18"/>
-          <p:cNvSpPr txBox="1"/>
-          <p:nvPr/>
-        </p:nvSpPr>
-        <p:spPr>
-          <a:xfrm>
-            <a:off x="4624730" y="2871216"/>
-            <a:ext cx="2942234" cy="457200"/>
-          </a:xfrm>
-          <a:prstGeom prst="rect">
-            <a:avLst/>
-          </a:prstGeom>
-          <a:noFill/>
-          <a:ln/>
-        </p:spPr>
-        <p:txBody>
-          <a:bodyPr wrap="square" lIns="0" tIns="0" rIns="0" bIns="0" rtlCol="0" anchor="t"/>
-          <a:lstStyle/>
-          <a:p>
-            <a:pPr marL="0" indent="0">
-              <a:lnSpc>
-                <a:spcPts val="1700"/>
-              </a:lnSpc>
-              <a:buNone/>
-            </a:pPr>
-            <a:r>
-              <a:rPr lang="en-US" sz="1400" b="1" dirty="0">
-                <a:solidFill>
-                  <a:srgbClr val="1E3A5F"/>
-                </a:solidFill>
-                <a:latin typeface="Arial" pitchFamily="34" charset="0"/>
-                <a:ea typeface="Arial" pitchFamily="34" charset="-122"/>
-                <a:cs typeface="Arial" pitchFamily="34" charset="-120"/>
-              </a:rPr>
-              <a:t>Mô hình 2 và demo thời gian thực</a:t>
-            </a:r>
-            <a:endParaRPr lang="en-US" sz="1400" dirty="0"/>
-          </a:p>
-        </p:txBody>
-      </p:sp>
-      <p:sp>
-        <p:nvSpPr>
-          <p:cNvPr id="21" name="Text 19"/>
-          <p:cNvSpPr txBox="1"/>
-          <p:nvPr/>
-        </p:nvSpPr>
-        <p:spPr>
-          <a:xfrm>
-            <a:off x="4624730" y="3401568"/>
-            <a:ext cx="2997098" cy="2121408"/>
-          </a:xfrm>
-          <a:prstGeom prst="rect">
-            <a:avLst/>
-          </a:prstGeom>
-          <a:noFill/>
-          <a:ln/>
-        </p:spPr>
-        <p:txBody>
-          <a:bodyPr wrap="square" lIns="0" tIns="0" rIns="0" bIns="0" rtlCol="0" anchor="t"/>
-          <a:lstStyle/>
           <a:p>
             <a:pPr marL="177800" indent="-177800">
               <a:lnSpc>
@@ -9991,6 +10611,28 @@
               <a:buChar char="•"/>
             </a:pPr>
             <a:r>
+              <a:rPr lang="en-US" sz="1150" dirty="0" err="1" smtClean="0">
+                <a:solidFill>
+                  <a:srgbClr val="3C4A5C"/>
+                </a:solidFill>
+                <a:latin typeface="Calibri" pitchFamily="34" charset="0"/>
+                <a:ea typeface="Calibri" pitchFamily="34" charset="-122"/>
+                <a:cs typeface="Calibri" pitchFamily="34" charset="-120"/>
+              </a:rPr>
+              <a:t>Ghép</a:t>
+            </a:r>
+            <a:r>
+              <a:rPr lang="en-US" sz="1150" dirty="0" smtClean="0">
+                <a:solidFill>
+                  <a:srgbClr val="3C4A5C"/>
+                </a:solidFill>
+                <a:latin typeface="Calibri" pitchFamily="34" charset="0"/>
+                <a:ea typeface="Calibri" pitchFamily="34" charset="-122"/>
+                <a:cs typeface="Calibri" pitchFamily="34" charset="-120"/>
+              </a:rPr>
+              <a:t> </a:t>
+            </a:r>
+            <a:r>
               <a:rPr lang="en-US" sz="1150" dirty="0">
                 <a:solidFill>
                   <a:srgbClr val="3C4A5C"/>
@@ -9999,21 +10641,19 @@
                 <a:ea typeface="Calibri" pitchFamily="34" charset="-122"/>
                 <a:cs typeface="Calibri" pitchFamily="34" charset="-120"/>
               </a:rPr>
-              <a:t>Cài PyTorch bản CPU, viết vòng lặp huấn luyện tối thiểu</a:t>
-            </a:r>
-            <a:endParaRPr lang="en-US" sz="1150" dirty="0"/>
-          </a:p>
-          <a:p>
-            <a:pPr marL="177800" indent="-177800">
-              <a:lnSpc>
-                <a:spcPts val="1500"/>
-              </a:lnSpc>
-              <a:spcAft>
-                <a:spcPts val="600"/>
-              </a:spcAft>
-              <a:buSzPct val="100000"/>
-              <a:buChar char="•"/>
-            </a:pPr>
+              <a:t>demo thời </a:t>
+            </a:r>
+            <a:r>
+              <a:rPr lang="en-US" sz="1150" dirty="0" err="1">
+                <a:solidFill>
+                  <a:srgbClr val="3C4A5C"/>
+                </a:solidFill>
+                <a:latin typeface="Calibri" pitchFamily="34" charset="0"/>
+                <a:ea typeface="Calibri" pitchFamily="34" charset="-122"/>
+                <a:cs typeface="Calibri" pitchFamily="34" charset="-120"/>
+              </a:rPr>
+              <a:t>gian</a:t>
+            </a:r>
             <a:r>
               <a:rPr lang="en-US" sz="1150" dirty="0">
                 <a:solidFill>
@@ -10023,79 +10663,18 @@
                 <a:ea typeface="Calibri" pitchFamily="34" charset="-122"/>
                 <a:cs typeface="Calibri" pitchFamily="34" charset="-120"/>
               </a:rPr>
-              <a:t>LSTM hai lớp, đầu vào 23 khớp × 2 tọa độ, kích thước ẩn 128, dropout 0.3</a:t>
-            </a:r>
-            <a:endParaRPr lang="en-US" sz="1150" dirty="0"/>
-          </a:p>
-          <a:p>
-            <a:pPr marL="177800" indent="-177800">
-              <a:lnSpc>
-                <a:spcPts val="1500"/>
-              </a:lnSpc>
-              <a:spcAft>
-                <a:spcPts val="600"/>
-              </a:spcAft>
-              <a:buSzPct val="100000"/>
-              <a:buChar char="•"/>
-            </a:pPr>
-            <a:r>
-              <a:rPr lang="en-US" sz="1150" dirty="0">
-                <a:solidFill>
-                  <a:srgbClr val="3C4A5C"/>
-                </a:solidFill>
-                <a:latin typeface="Calibri" pitchFamily="34" charset="0"/>
-                <a:ea typeface="Calibri" pitchFamily="34" charset="-122"/>
-                <a:cs typeface="Calibri" pitchFamily="34" charset="-120"/>
-              </a:rPr>
-              <a:t>Khảo sát độ dài cửa sổ 15 / 30 / 45 khung hình</a:t>
-            </a:r>
-            <a:endParaRPr lang="en-US" sz="1150" dirty="0"/>
-          </a:p>
-          <a:p>
-            <a:pPr marL="177800" indent="-177800">
-              <a:lnSpc>
-                <a:spcPts val="1500"/>
-              </a:lnSpc>
-              <a:spcAft>
-                <a:spcPts val="600"/>
-              </a:spcAft>
-              <a:buSzPct val="100000"/>
-              <a:buChar char="•"/>
-            </a:pPr>
-            <a:r>
-              <a:rPr lang="en-US" sz="1150" dirty="0">
-                <a:solidFill>
-                  <a:srgbClr val="3C4A5C"/>
-                </a:solidFill>
-                <a:latin typeface="Calibri" pitchFamily="34" charset="0"/>
-                <a:ea typeface="Calibri" pitchFamily="34" charset="-122"/>
-                <a:cs typeface="Calibri" pitchFamily="34" charset="-120"/>
-              </a:rPr>
-              <a:t>So sánh với rừng ngẫu nhiên trên đúng cách chia tập</a:t>
-            </a:r>
-            <a:endParaRPr lang="en-US" sz="1150" dirty="0"/>
-          </a:p>
-          <a:p>
-            <a:pPr marL="177800" indent="-177800">
-              <a:lnSpc>
-                <a:spcPts val="1500"/>
-              </a:lnSpc>
-              <a:spcAft>
-                <a:spcPts val="600"/>
-              </a:spcAft>
-              <a:buSzPct val="100000"/>
-              <a:buChar char="•"/>
-            </a:pPr>
-            <a:r>
-              <a:rPr lang="en-US" sz="1150" dirty="0">
-                <a:solidFill>
-                  <a:srgbClr val="3C4A5C"/>
-                </a:solidFill>
-                <a:latin typeface="Calibri" pitchFamily="34" charset="0"/>
-                <a:ea typeface="Calibri" pitchFamily="34" charset="-122"/>
-                <a:cs typeface="Calibri" pitchFamily="34" charset="-120"/>
-              </a:rPr>
-              <a:t>Ghép demo thời gian thực, làm mượt nhãn bằng bỏ phiếu 5 dự đoán</a:t>
+              <a:t> </a:t>
+            </a:r>
+            <a:r>
+              <a:rPr lang="en-US" sz="1150" dirty="0" err="1" smtClean="0">
+                <a:solidFill>
+                  <a:srgbClr val="3C4A5C"/>
+                </a:solidFill>
+                <a:latin typeface="Calibri" pitchFamily="34" charset="0"/>
+                <a:ea typeface="Calibri" pitchFamily="34" charset="-122"/>
+                <a:cs typeface="Calibri" pitchFamily="34" charset="-120"/>
+              </a:rPr>
+              <a:t>thực</a:t>
             </a:r>
             <a:endParaRPr lang="en-US" sz="1150" dirty="0"/>
           </a:p>

</xml_diff>

<commit_message>
update cmt day 1
</commit_message>
<xml_diff>
--- a/slides/bao-cao-buoi-1-nhan-dang-hanh-dong.pptx
+++ b/slides/bao-cao-buoi-1-nhan-dang-hanh-dong.pptx
@@ -3456,7 +3456,22 @@
               </a:rPr>
               <a:t>CPU - i3 12th, GPU – RTX 3050 8G</a:t>
             </a:r>
-            <a:endParaRPr lang="en-US" sz="1200" dirty="0"/>
+          </a:p>
+          <a:p>
+            <a:pPr marL="0" indent="0">
+              <a:lnSpc>
+                <a:spcPts val="1600"/>
+              </a:lnSpc>
+              <a:buNone/>
+            </a:pPr>
+            <a:endParaRPr lang="en-US" sz="1200" dirty="0">
+              <a:solidFill>
+                <a:srgbClr val="3C4A5C"/>
+              </a:solidFill>
+              <a:latin typeface="Calibri" pitchFamily="34" charset="0"/>
+              <a:ea typeface="Calibri" pitchFamily="34" charset="-122"/>
+              <a:cs typeface="Calibri" pitchFamily="34" charset="-120"/>
+            </a:endParaRPr>
           </a:p>
         </p:txBody>
       </p:sp>
@@ -3465,6 +3480,13 @@
   <p:clrMapOvr>
     <a:masterClrMapping/>
   </p:clrMapOvr>
+  <p:timing>
+    <p:tnLst>
+      <p:par>
+        <p:cTn id="1" dur="indefinite" restart="never" nodeType="tmRoot"/>
+      </p:par>
+    </p:tnLst>
+  </p:timing>
 </p:sld>
 </file>
 
@@ -5711,6 +5733,13 @@
   <p:clrMapOvr>
     <a:masterClrMapping/>
   </p:clrMapOvr>
+  <p:timing>
+    <p:tnLst>
+      <p:par>
+        <p:cTn id="1" dur="indefinite" restart="never" nodeType="tmRoot"/>
+      </p:par>
+    </p:tnLst>
+  </p:timing>
 </p:sld>
 </file>
 
@@ -6956,6 +6985,13 @@
   <p:clrMapOvr>
     <a:masterClrMapping/>
   </p:clrMapOvr>
+  <p:timing>
+    <p:tnLst>
+      <p:par>
+        <p:cTn id="1" dur="indefinite" restart="never" nodeType="tmRoot"/>
+      </p:par>
+    </p:tnLst>
+  </p:timing>
 </p:sld>
 </file>
 
@@ -8421,6 +8457,13 @@
   <p:clrMapOvr>
     <a:masterClrMapping/>
   </p:clrMapOvr>
+  <p:timing>
+    <p:tnLst>
+      <p:par>
+        <p:cTn id="1" dur="indefinite" restart="never" nodeType="tmRoot"/>
+      </p:par>
+    </p:tnLst>
+  </p:timing>
 </p:sld>
 </file>
 
@@ -9675,6 +9718,13 @@
   <p:clrMapOvr>
     <a:masterClrMapping/>
   </p:clrMapOvr>
+  <p:timing>
+    <p:tnLst>
+      <p:par>
+        <p:cTn id="1" dur="indefinite" restart="never" nodeType="tmRoot"/>
+      </p:par>
+    </p:tnLst>
+  </p:timing>
 </p:sld>
 </file>
 
@@ -10887,6 +10937,13 @@
   <p:clrMapOvr>
     <a:masterClrMapping/>
   </p:clrMapOvr>
+  <p:timing>
+    <p:tnLst>
+      <p:par>
+        <p:cTn id="1" dur="indefinite" restart="never" nodeType="tmRoot"/>
+      </p:par>
+    </p:tnLst>
+  </p:timing>
 </p:sld>
 </file>
 
@@ -12174,6 +12231,13 @@
   <p:clrMapOvr>
     <a:masterClrMapping/>
   </p:clrMapOvr>
+  <p:timing>
+    <p:tnLst>
+      <p:par>
+        <p:cTn id="1" dur="indefinite" restart="never" nodeType="tmRoot"/>
+      </p:par>
+    </p:tnLst>
+  </p:timing>
 </p:sld>
 </file>
 

</xml_diff>